<commit_message>
Add alliances dimension to FSI plan deck
Alliances become the eighth strategy question and workstream, with a slide
covering the current primary and specialised alliances and the questions to
answer for each.

Co-Authored-By: Claude Opus 5 <noreply@anthropic.com>
Claude-Session: https://claude.ai/code/session_01RbQ17qgK4LScEQt4Kxi5zh
</commit_message>
<xml_diff>
--- a/FSI strategy/EAIND-FSI-Strategy-Development-Plan.pptx
+++ b/FSI strategy/EAIND-FSI-Strategy-Development-Plan.pptx
@@ -15,9 +15,10 @@
     <p:sldId id="263" r:id="rId9"/>
     <p:sldId id="264" r:id="rId10"/>
     <p:sldId id="265" r:id="rId11"/>
+    <p:sldId id="266" r:id="rId12"/>
   </p:sldIdLst>
   <p:notesMasterIdLst>
-    <p:notesMasterId r:id="rId12"/>
+    <p:notesMasterId r:id="rId13"/>
   </p:notesMasterIdLst>
   <p:sldSz cx="12192000" cy="6858000"/>
   <p:notesSz cx="6858000" cy="12192000"/>
@@ -605,10 +606,9 @@
           <a:p>
             <a:r>
               <a:rPr lang="en-US" dirty="0"/>
-              <a:t>Close on two asks: confirm the principles, and nominate the workstream owners.
-Inputs are the long pole — pipeline, revenue by pillar and market, existing relationships, alliance status, delivery capacity and historical deal values all sit with different people. Chase them in the first 48 hours or week 1 slips.
-Decisions requested at sign-off: priority markets and segments, the target account list, revenue and margin targets, account ownership, and the investment and hiring asks coming out of the talent and eminence workstreams.
-Open items to resolve at kick-off: audience for this pack, the definition of partner for account ownership, and the start date.</a:t>
+              <a:t>Three weeks is the timebox given: the strategy should be finalised in no more than about three weeks. The constraint is deliberate — it forces decisions rather than analysis.
+Each week ends at a gate, and a gate is a decision taken, not a document circulated. If a gate cannot be closed, we escalate at the checkpoint rather than let the week slip.
+Start date to be set at kick-off.</a:t>
             </a:r>
             <a:endParaRPr lang="en-US" dirty="0"/>
           </a:p>
@@ -632,6 +632,97 @@
             <a:fld id="{F7021451-1387-4CA6-816F-3879F97B5CBC}" type="slidenum">
               <a:rPr lang="en-US"/>
               <a:t>10</a:t>
+            </a:fld>
+            <a:endParaRPr lang="en-US"/>
+          </a:p>
+        </p:txBody>
+      </p:sp>
+    </p:spTree>
+    <p:extLst>
+      <p:ext uri="{BB962C8B-B14F-4D97-AF65-F5344CB8AC3E}">
+        <p14:creationId xmlns:p14="http://schemas.microsoft.com/office/powerpoint/2010/main" val="1024086991"/>
+      </p:ext>
+    </p:extLst>
+  </p:cSld>
+  <p:clrMapOvr>
+    <a:masterClrMapping/>
+  </p:clrMapOvr>
+</p:notes>
+</file>
+
+<file path=ppt/notesSlides/notesSlide11.xml><?xml version="1.0" encoding="utf-8"?>
+<p:notes xmlns:a="http://schemas.openxmlformats.org/drawingml/2006/main" xmlns:r="http://schemas.openxmlformats.org/officeDocument/2006/relationships" xmlns:p="http://schemas.openxmlformats.org/presentationml/2006/main">
+  <p:cSld>
+    <p:spTree>
+      <p:nvGrpSpPr>
+        <p:cNvPr id="1" name=""/>
+        <p:cNvGrpSpPr/>
+        <p:nvPr/>
+      </p:nvGrpSpPr>
+      <p:grpSpPr>
+        <a:xfrm>
+          <a:off x="0" y="0"/>
+          <a:ext cx="0" cy="0"/>
+          <a:chOff x="0" y="0"/>
+          <a:chExt cx="0" cy="0"/>
+        </a:xfrm>
+      </p:grpSpPr>
+      <p:sp>
+        <p:nvSpPr>
+          <p:cNvPr id="2" name="Slide Image Placeholder 1"/>
+          <p:cNvSpPr>
+            <a:spLocks noGrp="1" noRot="1" noChangeAspect="1"/>
+          </p:cNvSpPr>
+          <p:nvPr>
+            <p:ph type="sldImg"/>
+          </p:nvPr>
+        </p:nvSpPr>
+        <p:spPr/>
+      </p:sp>
+      <p:sp>
+        <p:nvSpPr>
+          <p:cNvPr id="3" name="Notes Placeholder 2"/>
+          <p:cNvSpPr>
+            <a:spLocks noGrp="1"/>
+          </p:cNvSpPr>
+          <p:nvPr>
+            <p:ph type="body" idx="1"/>
+          </p:nvPr>
+        </p:nvSpPr>
+        <p:spPr/>
+        <p:txBody>
+          <a:bodyPr/>
+          <a:lstStyle/>
+          <a:p>
+            <a:r>
+              <a:rPr lang="en-US" dirty="0"/>
+              <a:t>Close on two asks: confirm the principles, and nominate the workstream owners.
+Inputs are the long pole — pipeline, revenue by pillar and market, existing relationships, alliance status, delivery capacity and historical deal values all sit with different people. Chase them in the first 48 hours or week 1 slips.
+Decisions requested at sign-off: priority markets and segments, the target account list, revenue and margin targets, account ownership, and the investment and hiring asks coming out of the talent and eminence workstreams.
+Open items to resolve at kick-off: audience for this pack, the definition of partner for account ownership, and the start date.</a:t>
+            </a:r>
+            <a:endParaRPr lang="en-US" dirty="0"/>
+          </a:p>
+        </p:txBody>
+      </p:sp>
+      <p:sp>
+        <p:nvSpPr>
+          <p:cNvPr id="4" name="Slide Number Placeholder 3"/>
+          <p:cNvSpPr>
+            <a:spLocks noGrp="1"/>
+          </p:cNvSpPr>
+          <p:nvPr>
+            <p:ph type="sldNum" sz="quarter" idx="10"/>
+          </p:nvPr>
+        </p:nvSpPr>
+        <p:spPr/>
+        <p:txBody>
+          <a:bodyPr/>
+          <a:lstStyle/>
+          <a:p>
+            <a:fld id="{F7021451-1387-4CA6-816F-3879F97B5CBC}" type="slidenum">
+              <a:rPr lang="en-US"/>
+              <a:t>11</a:t>
             </a:fld>
             <a:endParaRPr lang="en-US"/>
           </a:p>
@@ -1069,7 +1160,8 @@
 - WS4 Coverage and ownership: two distinct mappings — our partners to accounts (who owns the relationship) and alliance partners to accounts (who we go to market with, and what they drive).
 - WS5 Delivery model and readiness: largely inherited; confirm and note gaps.
 - WS6 Team and talent: see the talent slide.
-- WS7 Eminence and positioning: see the eminence slide.</a:t>
+- WS7 Eminence and positioning: see the eminence slide.
+- WS8 Alliances: see the alliances slide. Primary alliances today are Oracle, Google and Amazon; specialised alliances are Temenos and Intellect.</a:t>
             </a:r>
             <a:endParaRPr lang="en-US" dirty="0"/>
           </a:p>
@@ -1341,9 +1433,11 @@
           <a:p>
             <a:r>
               <a:rPr lang="en-US" dirty="0"/>
-              <a:t>Three weeks is the timebox given: the strategy should be finalised in no more than about three weeks. The constraint is deliberate — it forces decisions rather than analysis.
-Each week ends at a gate, and a gate is a decision taken, not a document circulated. If a gate cannot be closed, we escalate at the checkpoint rather than let the week slip.
-Start date to be set at kick-off.</a:t>
+              <a:t>Alliances were called out as important in implementation and technology work.
+Current alliances named: Oracle, Google and Amazon as the primary ones; Temenos and Intellect as specialised, banking-platform alliances. They are on the slide as current state, not as a conclusion — what we do with each is the open question.
+The work is to decide, per alliance: what we leverage it for, which of our integrated propositions it sits behind, what kind of relationship it is (co-sell, resell, delivery, referral), which markets and accounts it opens, and what it demands from us in certifications, trained staff and pipeline commitments.
+Two links to the rest of the strategy: the alliance map must reconcile with the account coverage map (an alliance that opens an account should show up against that account), and with the talent plan (certifications and accredited staff are a recruitment and training cost).
+If other alliances belong here — hyperscaler or platform vendors we do not yet work with, or regional players — the cycle is where we add them.</a:t>
             </a:r>
             <a:endParaRPr lang="en-US" dirty="0"/>
           </a:p>
@@ -1953,6 +2047,974 @@
     <p:bg>
       <p:bgPr>
         <a:solidFill>
+          <a:srgbClr val="FFFFFF"/>
+        </a:solidFill>
+      </p:bgPr>
+    </p:bg>
+    <p:spTree>
+      <p:nvGrpSpPr>
+        <p:cNvPr id="1" name=""/>
+        <p:cNvGrpSpPr/>
+        <p:nvPr/>
+      </p:nvGrpSpPr>
+      <p:grpSpPr>
+        <a:xfrm>
+          <a:off x="0" y="0"/>
+          <a:ext cx="0" cy="0"/>
+          <a:chOff x="0" y="0"/>
+          <a:chExt cx="0" cy="0"/>
+        </a:xfrm>
+      </p:grpSpPr>
+      <p:sp>
+        <p:nvSpPr>
+          <p:cNvPr id="2" name="Text 0"/>
+          <p:cNvSpPr txBox="1"/>
+          <p:nvPr/>
+        </p:nvSpPr>
+        <p:spPr>
+          <a:xfrm>
+            <a:off x="640080" y="411480"/>
+            <a:ext cx="10881360" cy="685800"/>
+          </a:xfrm>
+          <a:prstGeom prst="rect">
+            <a:avLst/>
+          </a:prstGeom>
+          <a:noFill/>
+          <a:ln/>
+        </p:spPr>
+        <p:txBody>
+          <a:bodyPr wrap="square" lIns="0" tIns="0" rIns="0" bIns="0" rtlCol="0" anchor="ctr"/>
+          <a:lstStyle/>
+          <a:p>
+            <a:pPr indent="0" marL="0">
+              <a:buNone/>
+            </a:pPr>
+            <a:r>
+              <a:rPr lang="en-US" sz="3600" b="1" dirty="0">
+                <a:solidFill>
+                  <a:srgbClr val="16203A"/>
+                </a:solidFill>
+                <a:latin typeface="Cambria" pitchFamily="34" charset="0"/>
+                <a:ea typeface="Cambria" pitchFamily="34" charset="-122"/>
+                <a:cs typeface="Cambria" pitchFamily="34" charset="-120"/>
+              </a:rPr>
+              <a:t>The three-week journey</a:t>
+            </a:r>
+            <a:endParaRPr lang="en-US" sz="3600" dirty="0"/>
+          </a:p>
+        </p:txBody>
+      </p:sp>
+      <p:sp>
+        <p:nvSpPr>
+          <p:cNvPr id="3" name="Text 1"/>
+          <p:cNvSpPr txBox="1"/>
+          <p:nvPr/>
+        </p:nvSpPr>
+        <p:spPr>
+          <a:xfrm>
+            <a:off x="640080" y="1133856"/>
+            <a:ext cx="10881360" cy="411480"/>
+          </a:xfrm>
+          <a:prstGeom prst="rect">
+            <a:avLst/>
+          </a:prstGeom>
+          <a:noFill/>
+          <a:ln/>
+        </p:spPr>
+        <p:txBody>
+          <a:bodyPr wrap="square" lIns="0" tIns="0" rIns="0" bIns="0" rtlCol="0" anchor="ctr"/>
+          <a:lstStyle/>
+          <a:p>
+            <a:pPr indent="0" marL="0">
+              <a:buNone/>
+            </a:pPr>
+            <a:r>
+              <a:rPr lang="en-US" sz="1450" dirty="0">
+                <a:solidFill>
+                  <a:srgbClr val="8792AB"/>
+                </a:solidFill>
+                <a:latin typeface="Calibri" pitchFamily="34" charset="0"/>
+                <a:ea typeface="Calibri" pitchFamily="34" charset="-122"/>
+                <a:cs typeface="Calibri" pitchFamily="34" charset="-120"/>
+              </a:rPr>
+              <a:t>Three weeks, three gates, one decision.</a:t>
+            </a:r>
+            <a:endParaRPr lang="en-US" sz="1450" dirty="0"/>
+          </a:p>
+        </p:txBody>
+      </p:sp>
+      <p:sp>
+        <p:nvSpPr>
+          <p:cNvPr id="4" name="Shape 2"/>
+          <p:cNvSpPr/>
+          <p:nvPr/>
+        </p:nvSpPr>
+        <p:spPr>
+          <a:xfrm>
+            <a:off x="640080" y="1828800"/>
+            <a:ext cx="3429000" cy="3840480"/>
+          </a:xfrm>
+          <a:prstGeom prst="roundRect">
+            <a:avLst>
+              <a:gd name="adj" fmla="val 3200"/>
+            </a:avLst>
+          </a:prstGeom>
+          <a:solidFill>
+            <a:srgbClr val="EDF2FA"/>
+          </a:solidFill>
+          <a:ln/>
+        </p:spPr>
+      </p:sp>
+      <p:sp>
+        <p:nvSpPr>
+          <p:cNvPr id="5" name="Shape 3"/>
+          <p:cNvSpPr/>
+          <p:nvPr/>
+        </p:nvSpPr>
+        <p:spPr>
+          <a:xfrm>
+            <a:off x="640080" y="1828800"/>
+            <a:ext cx="3429000" cy="685800"/>
+          </a:xfrm>
+          <a:prstGeom prst="rect">
+            <a:avLst/>
+          </a:prstGeom>
+          <a:solidFill>
+            <a:srgbClr val="1E2761"/>
+          </a:solidFill>
+          <a:ln/>
+        </p:spPr>
+      </p:sp>
+      <p:sp>
+        <p:nvSpPr>
+          <p:cNvPr id="6" name="Text 4"/>
+          <p:cNvSpPr txBox="1"/>
+          <p:nvPr/>
+        </p:nvSpPr>
+        <p:spPr>
+          <a:xfrm>
+            <a:off x="914400" y="1828800"/>
+            <a:ext cx="2926080" cy="685800"/>
+          </a:xfrm>
+          <a:prstGeom prst="rect">
+            <a:avLst/>
+          </a:prstGeom>
+          <a:noFill/>
+          <a:ln/>
+        </p:spPr>
+        <p:txBody>
+          <a:bodyPr wrap="square" lIns="0" tIns="0" rIns="0" bIns="0" rtlCol="0" anchor="ctr"/>
+          <a:lstStyle/>
+          <a:p>
+            <a:pPr indent="0" marL="0">
+              <a:buNone/>
+            </a:pPr>
+            <a:r>
+              <a:rPr lang="en-US" sz="1800" b="1" dirty="0">
+                <a:solidFill>
+                  <a:srgbClr val="FFFFFF"/>
+                </a:solidFill>
+                <a:latin typeface="Calibri" pitchFamily="34" charset="0"/>
+                <a:ea typeface="Calibri" pitchFamily="34" charset="-122"/>
+                <a:cs typeface="Calibri" pitchFamily="34" charset="-120"/>
+              </a:rPr>
+              <a:t>Week 1  ·  Frame</a:t>
+            </a:r>
+            <a:endParaRPr lang="en-US" sz="1800" dirty="0"/>
+          </a:p>
+        </p:txBody>
+      </p:sp>
+      <p:sp>
+        <p:nvSpPr>
+          <p:cNvPr id="7" name="Text 5"/>
+          <p:cNvSpPr txBox="1"/>
+          <p:nvPr/>
+        </p:nvSpPr>
+        <p:spPr>
+          <a:xfrm>
+            <a:off x="914400" y="2743200"/>
+            <a:ext cx="2880360" cy="1920240"/>
+          </a:xfrm>
+          <a:prstGeom prst="rect">
+            <a:avLst/>
+          </a:prstGeom>
+          <a:noFill/>
+          <a:ln/>
+        </p:spPr>
+        <p:txBody>
+          <a:bodyPr wrap="square" lIns="0" tIns="0" rIns="0" bIns="0" rtlCol="0" anchor="ctr"/>
+          <a:lstStyle/>
+          <a:p>
+            <a:pPr marL="342900" indent="-342900">
+              <a:spcAft>
+                <a:spcPts val="900"/>
+              </a:spcAft>
+              <a:buSzPct val="100000"/>
+              <a:buChar char="•"/>
+            </a:pPr>
+            <a:r>
+              <a:rPr lang="en-US" sz="1250" dirty="0">
+                <a:solidFill>
+                  <a:srgbClr val="44506B"/>
+                </a:solidFill>
+                <a:latin typeface="Calibri" pitchFamily="34" charset="0"/>
+                <a:ea typeface="Calibri" pitchFamily="34" charset="-122"/>
+                <a:cs typeface="Calibri" pitchFamily="34" charset="-120"/>
+              </a:rPr>
+              <a:t>Baseline current position and credentials</a:t>
+            </a:r>
+            <a:endParaRPr lang="en-US" sz="1250" dirty="0"/>
+          </a:p>
+          <a:p>
+            <a:pPr marL="342900" indent="-342900">
+              <a:spcAft>
+                <a:spcPts val="900"/>
+              </a:spcAft>
+              <a:buSzPct val="100000"/>
+              <a:buChar char="•"/>
+            </a:pPr>
+            <a:r>
+              <a:rPr lang="en-US" sz="1250" dirty="0">
+                <a:solidFill>
+                  <a:srgbClr val="44506B"/>
+                </a:solidFill>
+                <a:latin typeface="Calibri" pitchFamily="34" charset="0"/>
+                <a:ea typeface="Calibri" pitchFamily="34" charset="-122"/>
+                <a:cs typeface="Calibri" pitchFamily="34" charset="-120"/>
+              </a:rPr>
+              <a:t>Prioritise markets and segments</a:t>
+            </a:r>
+            <a:endParaRPr lang="en-US" sz="1250" dirty="0"/>
+          </a:p>
+          <a:p>
+            <a:pPr marL="342900" indent="-342900">
+              <a:spcAft>
+                <a:spcPts val="900"/>
+              </a:spcAft>
+              <a:buSzPct val="100000"/>
+              <a:buChar char="•"/>
+            </a:pPr>
+            <a:r>
+              <a:rPr lang="en-US" sz="1250" dirty="0">
+                <a:solidFill>
+                  <a:srgbClr val="44506B"/>
+                </a:solidFill>
+                <a:latin typeface="Calibri" pitchFamily="34" charset="0"/>
+                <a:ea typeface="Calibri" pitchFamily="34" charset="-122"/>
+                <a:cs typeface="Calibri" pitchFamily="34" charset="-120"/>
+              </a:rPr>
+              <a:t>Build the account longlist</a:t>
+            </a:r>
+            <a:endParaRPr lang="en-US" sz="1250" dirty="0"/>
+          </a:p>
+          <a:p>
+            <a:pPr marL="342900" indent="-342900">
+              <a:spcAft>
+                <a:spcPts val="900"/>
+              </a:spcAft>
+              <a:buSzPct val="100000"/>
+              <a:buChar char="•"/>
+            </a:pPr>
+            <a:r>
+              <a:rPr lang="en-US" sz="1250" dirty="0">
+                <a:solidFill>
+                  <a:srgbClr val="44506B"/>
+                </a:solidFill>
+                <a:latin typeface="Calibri" pitchFamily="34" charset="0"/>
+                <a:ea typeface="Calibri" pitchFamily="34" charset="-122"/>
+                <a:cs typeface="Calibri" pitchFamily="34" charset="-120"/>
+              </a:rPr>
+              <a:t>Draft the proposition catalogue</a:t>
+            </a:r>
+            <a:endParaRPr lang="en-US" sz="1250" dirty="0"/>
+          </a:p>
+          <a:p>
+            <a:pPr marL="342900" indent="-342900">
+              <a:spcAft>
+                <a:spcPts val="900"/>
+              </a:spcAft>
+              <a:buSzPct val="100000"/>
+              <a:buChar char="•"/>
+            </a:pPr>
+            <a:r>
+              <a:rPr lang="en-US" sz="1250" dirty="0">
+                <a:solidFill>
+                  <a:srgbClr val="44506B"/>
+                </a:solidFill>
+                <a:latin typeface="Calibri" pitchFamily="34" charset="0"/>
+                <a:ea typeface="Calibri" pitchFamily="34" charset="-122"/>
+                <a:cs typeface="Calibri" pitchFamily="34" charset="-120"/>
+              </a:rPr>
+              <a:t>Baseline the team we have today</a:t>
+            </a:r>
+            <a:endParaRPr lang="en-US" sz="1250" dirty="0"/>
+          </a:p>
+        </p:txBody>
+      </p:sp>
+      <p:sp>
+        <p:nvSpPr>
+          <p:cNvPr id="8" name="Text 6"/>
+          <p:cNvSpPr txBox="1"/>
+          <p:nvPr/>
+        </p:nvSpPr>
+        <p:spPr>
+          <a:xfrm>
+            <a:off x="914400" y="4892040"/>
+            <a:ext cx="2880360" cy="594360"/>
+          </a:xfrm>
+          <a:prstGeom prst="rect">
+            <a:avLst/>
+          </a:prstGeom>
+          <a:noFill/>
+          <a:ln/>
+        </p:spPr>
+        <p:txBody>
+          <a:bodyPr wrap="square" lIns="0" tIns="0" rIns="0" bIns="0" rtlCol="0" anchor="ctr"/>
+          <a:lstStyle/>
+          <a:p>
+            <a:pPr indent="0" marL="0">
+              <a:buNone/>
+            </a:pPr>
+            <a:r>
+              <a:rPr lang="en-US" sz="1200" b="1" dirty="0">
+                <a:solidFill>
+                  <a:srgbClr val="B8862B"/>
+                </a:solidFill>
+                <a:latin typeface="Calibri" pitchFamily="34" charset="0"/>
+                <a:ea typeface="Calibri" pitchFamily="34" charset="-122"/>
+                <a:cs typeface="Calibri" pitchFamily="34" charset="-120"/>
+              </a:rPr>
+              <a:t>Gate: agreed market and segment priorities</a:t>
+            </a:r>
+            <a:endParaRPr lang="en-US" sz="1200" dirty="0"/>
+          </a:p>
+        </p:txBody>
+      </p:sp>
+      <p:sp>
+        <p:nvSpPr>
+          <p:cNvPr id="9" name="Text 7"/>
+          <p:cNvSpPr txBox="1"/>
+          <p:nvPr/>
+        </p:nvSpPr>
+        <p:spPr>
+          <a:xfrm>
+            <a:off x="4096512" y="3474720"/>
+            <a:ext cx="256032" cy="457200"/>
+          </a:xfrm>
+          <a:prstGeom prst="rect">
+            <a:avLst/>
+          </a:prstGeom>
+          <a:noFill/>
+          <a:ln/>
+        </p:spPr>
+        <p:txBody>
+          <a:bodyPr wrap="square" lIns="0" tIns="0" rIns="0" bIns="0" rtlCol="0" anchor="ctr"/>
+          <a:lstStyle/>
+          <a:p>
+            <a:pPr algn="ctr" indent="0" marL="0">
+              <a:buNone/>
+            </a:pPr>
+            <a:r>
+              <a:rPr lang="en-US" sz="2000" dirty="0">
+                <a:solidFill>
+                  <a:srgbClr val="8792AB"/>
+                </a:solidFill>
+                <a:latin typeface="Calibri" pitchFamily="34" charset="0"/>
+                <a:ea typeface="Calibri" pitchFamily="34" charset="-122"/>
+                <a:cs typeface="Calibri" pitchFamily="34" charset="-120"/>
+              </a:rPr>
+              <a:t>→</a:t>
+            </a:r>
+            <a:endParaRPr lang="en-US" sz="2000" dirty="0"/>
+          </a:p>
+        </p:txBody>
+      </p:sp>
+      <p:sp>
+        <p:nvSpPr>
+          <p:cNvPr id="10" name="Shape 8"/>
+          <p:cNvSpPr/>
+          <p:nvPr/>
+        </p:nvSpPr>
+        <p:spPr>
+          <a:xfrm>
+            <a:off x="4361688" y="1828800"/>
+            <a:ext cx="3429000" cy="3840480"/>
+          </a:xfrm>
+          <a:prstGeom prst="roundRect">
+            <a:avLst>
+              <a:gd name="adj" fmla="val 3200"/>
+            </a:avLst>
+          </a:prstGeom>
+          <a:solidFill>
+            <a:srgbClr val="EDF2FA"/>
+          </a:solidFill>
+          <a:ln/>
+        </p:spPr>
+      </p:sp>
+      <p:sp>
+        <p:nvSpPr>
+          <p:cNvPr id="11" name="Shape 9"/>
+          <p:cNvSpPr/>
+          <p:nvPr/>
+        </p:nvSpPr>
+        <p:spPr>
+          <a:xfrm>
+            <a:off x="4361688" y="1828800"/>
+            <a:ext cx="3429000" cy="685800"/>
+          </a:xfrm>
+          <a:prstGeom prst="rect">
+            <a:avLst/>
+          </a:prstGeom>
+          <a:solidFill>
+            <a:srgbClr val="3E5C8A"/>
+          </a:solidFill>
+          <a:ln/>
+        </p:spPr>
+      </p:sp>
+      <p:sp>
+        <p:nvSpPr>
+          <p:cNvPr id="12" name="Text 10"/>
+          <p:cNvSpPr txBox="1"/>
+          <p:nvPr/>
+        </p:nvSpPr>
+        <p:spPr>
+          <a:xfrm>
+            <a:off x="4636008" y="1828800"/>
+            <a:ext cx="2926080" cy="685800"/>
+          </a:xfrm>
+          <a:prstGeom prst="rect">
+            <a:avLst/>
+          </a:prstGeom>
+          <a:noFill/>
+          <a:ln/>
+        </p:spPr>
+        <p:txBody>
+          <a:bodyPr wrap="square" lIns="0" tIns="0" rIns="0" bIns="0" rtlCol="0" anchor="ctr"/>
+          <a:lstStyle/>
+          <a:p>
+            <a:pPr indent="0" marL="0">
+              <a:buNone/>
+            </a:pPr>
+            <a:r>
+              <a:rPr lang="en-US" sz="1800" b="1" dirty="0">
+                <a:solidFill>
+                  <a:srgbClr val="FFFFFF"/>
+                </a:solidFill>
+                <a:latin typeface="Calibri" pitchFamily="34" charset="0"/>
+                <a:ea typeface="Calibri" pitchFamily="34" charset="-122"/>
+                <a:cs typeface="Calibri" pitchFamily="34" charset="-120"/>
+              </a:rPr>
+              <a:t>Week 2  ·  Define</a:t>
+            </a:r>
+            <a:endParaRPr lang="en-US" sz="1800" dirty="0"/>
+          </a:p>
+        </p:txBody>
+      </p:sp>
+      <p:sp>
+        <p:nvSpPr>
+          <p:cNvPr id="13" name="Text 11"/>
+          <p:cNvSpPr txBox="1"/>
+          <p:nvPr/>
+        </p:nvSpPr>
+        <p:spPr>
+          <a:xfrm>
+            <a:off x="4636008" y="2743200"/>
+            <a:ext cx="2880360" cy="1920240"/>
+          </a:xfrm>
+          <a:prstGeom prst="rect">
+            <a:avLst/>
+          </a:prstGeom>
+          <a:noFill/>
+          <a:ln/>
+        </p:spPr>
+        <p:txBody>
+          <a:bodyPr wrap="square" lIns="0" tIns="0" rIns="0" bIns="0" rtlCol="0" anchor="ctr"/>
+          <a:lstStyle/>
+          <a:p>
+            <a:pPr marL="342900" indent="-342900">
+              <a:spcAft>
+                <a:spcPts val="900"/>
+              </a:spcAft>
+              <a:buSzPct val="100000"/>
+              <a:buChar char="•"/>
+            </a:pPr>
+            <a:r>
+              <a:rPr lang="en-US" sz="1250" dirty="0">
+                <a:solidFill>
+                  <a:srgbClr val="44506B"/>
+                </a:solidFill>
+                <a:latin typeface="Calibri" pitchFamily="34" charset="0"/>
+                <a:ea typeface="Calibri" pitchFamily="34" charset="-122"/>
+                <a:cs typeface="Calibri" pitchFamily="34" charset="-120"/>
+              </a:rPr>
+              <a:t>Lock propositions and permitted variants</a:t>
+            </a:r>
+            <a:endParaRPr lang="en-US" sz="1250" dirty="0"/>
+          </a:p>
+          <a:p>
+            <a:pPr marL="342900" indent="-342900">
+              <a:spcAft>
+                <a:spcPts val="900"/>
+              </a:spcAft>
+              <a:buSzPct val="100000"/>
+              <a:buChar char="•"/>
+            </a:pPr>
+            <a:r>
+              <a:rPr lang="en-US" sz="1250" dirty="0">
+                <a:solidFill>
+                  <a:srgbClr val="44506B"/>
+                </a:solidFill>
+                <a:latin typeface="Calibri" pitchFamily="34" charset="0"/>
+                <a:ea typeface="Calibri" pitchFamily="34" charset="-122"/>
+                <a:cs typeface="Calibri" pitchFamily="34" charset="-120"/>
+              </a:rPr>
+              <a:t>Benchmark deal sizes and pricing</a:t>
+            </a:r>
+            <a:endParaRPr lang="en-US" sz="1250" dirty="0"/>
+          </a:p>
+          <a:p>
+            <a:pPr marL="342900" indent="-342900">
+              <a:spcAft>
+                <a:spcPts val="900"/>
+              </a:spcAft>
+              <a:buSzPct val="100000"/>
+              <a:buChar char="•"/>
+            </a:pPr>
+            <a:r>
+              <a:rPr lang="en-US" sz="1250" dirty="0">
+                <a:solidFill>
+                  <a:srgbClr val="44506B"/>
+                </a:solidFill>
+                <a:latin typeface="Calibri" pitchFamily="34" charset="0"/>
+                <a:ea typeface="Calibri" pitchFamily="34" charset="-122"/>
+                <a:cs typeface="Calibri" pitchFamily="34" charset="-120"/>
+              </a:rPr>
+              <a:t>Shortlist target accounts</a:t>
+            </a:r>
+            <a:endParaRPr lang="en-US" sz="1250" dirty="0"/>
+          </a:p>
+          <a:p>
+            <a:pPr marL="342900" indent="-342900">
+              <a:spcAft>
+                <a:spcPts val="900"/>
+              </a:spcAft>
+              <a:buSzPct val="100000"/>
+              <a:buChar char="•"/>
+            </a:pPr>
+            <a:r>
+              <a:rPr lang="en-US" sz="1250" dirty="0">
+                <a:solidFill>
+                  <a:srgbClr val="44506B"/>
+                </a:solidFill>
+                <a:latin typeface="Calibri" pitchFamily="34" charset="0"/>
+                <a:ea typeface="Calibri" pitchFamily="34" charset="-122"/>
+                <a:cs typeface="Calibri" pitchFamily="34" charset="-120"/>
+              </a:rPr>
+              <a:t>Map alliances to offerings</a:t>
+            </a:r>
+            <a:endParaRPr lang="en-US" sz="1250" dirty="0"/>
+          </a:p>
+          <a:p>
+            <a:pPr marL="342900" indent="-342900">
+              <a:spcAft>
+                <a:spcPts val="900"/>
+              </a:spcAft>
+              <a:buSzPct val="100000"/>
+              <a:buChar char="•"/>
+            </a:pPr>
+            <a:r>
+              <a:rPr lang="en-US" sz="1250" dirty="0">
+                <a:solidFill>
+                  <a:srgbClr val="44506B"/>
+                </a:solidFill>
+                <a:latin typeface="Calibri" pitchFamily="34" charset="0"/>
+                <a:ea typeface="Calibri" pitchFamily="34" charset="-122"/>
+                <a:cs typeface="Calibri" pitchFamily="34" charset="-120"/>
+              </a:rPr>
+              <a:t>Size the capacity each target implies</a:t>
+            </a:r>
+            <a:endParaRPr lang="en-US" sz="1250" dirty="0"/>
+          </a:p>
+        </p:txBody>
+      </p:sp>
+      <p:sp>
+        <p:nvSpPr>
+          <p:cNvPr id="14" name="Text 12"/>
+          <p:cNvSpPr txBox="1"/>
+          <p:nvPr/>
+        </p:nvSpPr>
+        <p:spPr>
+          <a:xfrm>
+            <a:off x="4636008" y="4892040"/>
+            <a:ext cx="2880360" cy="594360"/>
+          </a:xfrm>
+          <a:prstGeom prst="rect">
+            <a:avLst/>
+          </a:prstGeom>
+          <a:noFill/>
+          <a:ln/>
+        </p:spPr>
+        <p:txBody>
+          <a:bodyPr wrap="square" lIns="0" tIns="0" rIns="0" bIns="0" rtlCol="0" anchor="ctr"/>
+          <a:lstStyle/>
+          <a:p>
+            <a:pPr indent="0" marL="0">
+              <a:buNone/>
+            </a:pPr>
+            <a:r>
+              <a:rPr lang="en-US" sz="1200" b="1" dirty="0">
+                <a:solidFill>
+                  <a:srgbClr val="B8862B"/>
+                </a:solidFill>
+                <a:latin typeface="Calibri" pitchFamily="34" charset="0"/>
+                <a:ea typeface="Calibri" pitchFamily="34" charset="-122"/>
+                <a:cs typeface="Calibri" pitchFamily="34" charset="-120"/>
+              </a:rPr>
+              <a:t>Gate: agreed catalogue and shortlist</a:t>
+            </a:r>
+            <a:endParaRPr lang="en-US" sz="1200" dirty="0"/>
+          </a:p>
+        </p:txBody>
+      </p:sp>
+      <p:sp>
+        <p:nvSpPr>
+          <p:cNvPr id="15" name="Text 13"/>
+          <p:cNvSpPr txBox="1"/>
+          <p:nvPr/>
+        </p:nvSpPr>
+        <p:spPr>
+          <a:xfrm>
+            <a:off x="7818120" y="3474720"/>
+            <a:ext cx="256032" cy="457200"/>
+          </a:xfrm>
+          <a:prstGeom prst="rect">
+            <a:avLst/>
+          </a:prstGeom>
+          <a:noFill/>
+          <a:ln/>
+        </p:spPr>
+        <p:txBody>
+          <a:bodyPr wrap="square" lIns="0" tIns="0" rIns="0" bIns="0" rtlCol="0" anchor="ctr"/>
+          <a:lstStyle/>
+          <a:p>
+            <a:pPr algn="ctr" indent="0" marL="0">
+              <a:buNone/>
+            </a:pPr>
+            <a:r>
+              <a:rPr lang="en-US" sz="2000" dirty="0">
+                <a:solidFill>
+                  <a:srgbClr val="8792AB"/>
+                </a:solidFill>
+                <a:latin typeface="Calibri" pitchFamily="34" charset="0"/>
+                <a:ea typeface="Calibri" pitchFamily="34" charset="-122"/>
+                <a:cs typeface="Calibri" pitchFamily="34" charset="-120"/>
+              </a:rPr>
+              <a:t>→</a:t>
+            </a:r>
+            <a:endParaRPr lang="en-US" sz="2000" dirty="0"/>
+          </a:p>
+        </p:txBody>
+      </p:sp>
+      <p:sp>
+        <p:nvSpPr>
+          <p:cNvPr id="16" name="Shape 14"/>
+          <p:cNvSpPr/>
+          <p:nvPr/>
+        </p:nvSpPr>
+        <p:spPr>
+          <a:xfrm>
+            <a:off x="8083296" y="1828800"/>
+            <a:ext cx="3429000" cy="3840480"/>
+          </a:xfrm>
+          <a:prstGeom prst="roundRect">
+            <a:avLst>
+              <a:gd name="adj" fmla="val 3200"/>
+            </a:avLst>
+          </a:prstGeom>
+          <a:solidFill>
+            <a:srgbClr val="EDF2FA"/>
+          </a:solidFill>
+          <a:ln/>
+        </p:spPr>
+      </p:sp>
+      <p:sp>
+        <p:nvSpPr>
+          <p:cNvPr id="17" name="Shape 15"/>
+          <p:cNvSpPr/>
+          <p:nvPr/>
+        </p:nvSpPr>
+        <p:spPr>
+          <a:xfrm>
+            <a:off x="8083296" y="1828800"/>
+            <a:ext cx="3429000" cy="685800"/>
+          </a:xfrm>
+          <a:prstGeom prst="rect">
+            <a:avLst/>
+          </a:prstGeom>
+          <a:solidFill>
+            <a:srgbClr val="1E2761"/>
+          </a:solidFill>
+          <a:ln/>
+        </p:spPr>
+      </p:sp>
+      <p:sp>
+        <p:nvSpPr>
+          <p:cNvPr id="18" name="Text 16"/>
+          <p:cNvSpPr txBox="1"/>
+          <p:nvPr/>
+        </p:nvSpPr>
+        <p:spPr>
+          <a:xfrm>
+            <a:off x="8357616" y="1828800"/>
+            <a:ext cx="2926080" cy="685800"/>
+          </a:xfrm>
+          <a:prstGeom prst="rect">
+            <a:avLst/>
+          </a:prstGeom>
+          <a:noFill/>
+          <a:ln/>
+        </p:spPr>
+        <p:txBody>
+          <a:bodyPr wrap="square" lIns="0" tIns="0" rIns="0" bIns="0" rtlCol="0" anchor="ctr"/>
+          <a:lstStyle/>
+          <a:p>
+            <a:pPr indent="0" marL="0">
+              <a:buNone/>
+            </a:pPr>
+            <a:r>
+              <a:rPr lang="en-US" sz="1800" b="1" dirty="0">
+                <a:solidFill>
+                  <a:srgbClr val="FFFFFF"/>
+                </a:solidFill>
+                <a:latin typeface="Calibri" pitchFamily="34" charset="0"/>
+                <a:ea typeface="Calibri" pitchFamily="34" charset="-122"/>
+                <a:cs typeface="Calibri" pitchFamily="34" charset="-120"/>
+              </a:rPr>
+              <a:t>Week 3  ·  Commit</a:t>
+            </a:r>
+            <a:endParaRPr lang="en-US" sz="1800" dirty="0"/>
+          </a:p>
+        </p:txBody>
+      </p:sp>
+      <p:sp>
+        <p:nvSpPr>
+          <p:cNvPr id="19" name="Text 17"/>
+          <p:cNvSpPr txBox="1"/>
+          <p:nvPr/>
+        </p:nvSpPr>
+        <p:spPr>
+          <a:xfrm>
+            <a:off x="8357616" y="2743200"/>
+            <a:ext cx="2880360" cy="1920240"/>
+          </a:xfrm>
+          <a:prstGeom prst="rect">
+            <a:avLst/>
+          </a:prstGeom>
+          <a:noFill/>
+          <a:ln/>
+        </p:spPr>
+        <p:txBody>
+          <a:bodyPr wrap="square" lIns="0" tIns="0" rIns="0" bIns="0" rtlCol="0" anchor="ctr"/>
+          <a:lstStyle/>
+          <a:p>
+            <a:pPr marL="342900" indent="-342900">
+              <a:spcAft>
+                <a:spcPts val="900"/>
+              </a:spcAft>
+              <a:buSzPct val="100000"/>
+              <a:buChar char="•"/>
+            </a:pPr>
+            <a:r>
+              <a:rPr lang="en-US" sz="1250" dirty="0">
+                <a:solidFill>
+                  <a:srgbClr val="44506B"/>
+                </a:solidFill>
+                <a:latin typeface="Calibri" pitchFamily="34" charset="0"/>
+                <a:ea typeface="Calibri" pitchFamily="34" charset="-122"/>
+                <a:cs typeface="Calibri" pitchFamily="34" charset="-120"/>
+              </a:rPr>
+              <a:t>Set revenue targets by market and offering</a:t>
+            </a:r>
+            <a:endParaRPr lang="en-US" sz="1250" dirty="0"/>
+          </a:p>
+          <a:p>
+            <a:pPr marL="342900" indent="-342900">
+              <a:spcAft>
+                <a:spcPts val="900"/>
+              </a:spcAft>
+              <a:buSzPct val="100000"/>
+              <a:buChar char="•"/>
+            </a:pPr>
+            <a:r>
+              <a:rPr lang="en-US" sz="1250" dirty="0">
+                <a:solidFill>
+                  <a:srgbClr val="44506B"/>
+                </a:solidFill>
+                <a:latin typeface="Calibri" pitchFamily="34" charset="0"/>
+                <a:ea typeface="Calibri" pitchFamily="34" charset="-122"/>
+                <a:cs typeface="Calibri" pitchFamily="34" charset="-120"/>
+              </a:rPr>
+              <a:t>Assign an owner to every account</a:t>
+            </a:r>
+            <a:endParaRPr lang="en-US" sz="1250" dirty="0"/>
+          </a:p>
+          <a:p>
+            <a:pPr marL="342900" indent="-342900">
+              <a:spcAft>
+                <a:spcPts val="900"/>
+              </a:spcAft>
+              <a:buSzPct val="100000"/>
+              <a:buChar char="•"/>
+            </a:pPr>
+            <a:r>
+              <a:rPr lang="en-US" sz="1250" dirty="0">
+                <a:solidFill>
+                  <a:srgbClr val="44506B"/>
+                </a:solidFill>
+                <a:latin typeface="Calibri" pitchFamily="34" charset="0"/>
+                <a:ea typeface="Calibri" pitchFamily="34" charset="-122"/>
+                <a:cs typeface="Calibri" pitchFamily="34" charset="-120"/>
+              </a:rPr>
+              <a:t>Agree the team model and recruitment plan</a:t>
+            </a:r>
+            <a:endParaRPr lang="en-US" sz="1250" dirty="0"/>
+          </a:p>
+          <a:p>
+            <a:pPr marL="342900" indent="-342900">
+              <a:spcAft>
+                <a:spcPts val="900"/>
+              </a:spcAft>
+              <a:buSzPct val="100000"/>
+              <a:buChar char="•"/>
+            </a:pPr>
+            <a:r>
+              <a:rPr lang="en-US" sz="1250" dirty="0">
+                <a:solidFill>
+                  <a:srgbClr val="44506B"/>
+                </a:solidFill>
+                <a:latin typeface="Calibri" pitchFamily="34" charset="0"/>
+                <a:ea typeface="Calibri" pitchFamily="34" charset="-122"/>
+                <a:cs typeface="Calibri" pitchFamily="34" charset="-120"/>
+              </a:rPr>
+              <a:t>Set the eminence calendar</a:t>
+            </a:r>
+            <a:endParaRPr lang="en-US" sz="1250" dirty="0"/>
+          </a:p>
+          <a:p>
+            <a:pPr marL="342900" indent="-342900">
+              <a:spcAft>
+                <a:spcPts val="900"/>
+              </a:spcAft>
+              <a:buSzPct val="100000"/>
+              <a:buChar char="•"/>
+            </a:pPr>
+            <a:r>
+              <a:rPr lang="en-US" sz="1250" dirty="0">
+                <a:solidFill>
+                  <a:srgbClr val="44506B"/>
+                </a:solidFill>
+                <a:latin typeface="Calibri" pitchFamily="34" charset="0"/>
+                <a:ea typeface="Calibri" pitchFamily="34" charset="-122"/>
+                <a:cs typeface="Calibri" pitchFamily="34" charset="-120"/>
+              </a:rPr>
+              <a:t>Build the activation plan and sign off</a:t>
+            </a:r>
+            <a:endParaRPr lang="en-US" sz="1250" dirty="0"/>
+          </a:p>
+        </p:txBody>
+      </p:sp>
+      <p:sp>
+        <p:nvSpPr>
+          <p:cNvPr id="20" name="Text 18"/>
+          <p:cNvSpPr txBox="1"/>
+          <p:nvPr/>
+        </p:nvSpPr>
+        <p:spPr>
+          <a:xfrm>
+            <a:off x="8357616" y="4892040"/>
+            <a:ext cx="2880360" cy="594360"/>
+          </a:xfrm>
+          <a:prstGeom prst="rect">
+            <a:avLst/>
+          </a:prstGeom>
+          <a:noFill/>
+          <a:ln/>
+        </p:spPr>
+        <p:txBody>
+          <a:bodyPr wrap="square" lIns="0" tIns="0" rIns="0" bIns="0" rtlCol="0" anchor="ctr"/>
+          <a:lstStyle/>
+          <a:p>
+            <a:pPr indent="0" marL="0">
+              <a:buNone/>
+            </a:pPr>
+            <a:r>
+              <a:rPr lang="en-US" sz="1200" b="1" dirty="0">
+                <a:solidFill>
+                  <a:srgbClr val="B8862B"/>
+                </a:solidFill>
+                <a:latin typeface="Calibri" pitchFamily="34" charset="0"/>
+                <a:ea typeface="Calibri" pitchFamily="34" charset="-122"/>
+                <a:cs typeface="Calibri" pitchFamily="34" charset="-120"/>
+              </a:rPr>
+              <a:t>Gate: strategy signed off</a:t>
+            </a:r>
+            <a:endParaRPr lang="en-US" sz="1200" dirty="0"/>
+          </a:p>
+        </p:txBody>
+      </p:sp>
+      <p:sp>
+        <p:nvSpPr>
+          <p:cNvPr id="21" name="Text 19"/>
+          <p:cNvSpPr txBox="1"/>
+          <p:nvPr/>
+        </p:nvSpPr>
+        <p:spPr>
+          <a:xfrm>
+            <a:off x="640080" y="5852160"/>
+            <a:ext cx="5486400" cy="320040"/>
+          </a:xfrm>
+          <a:prstGeom prst="rect">
+            <a:avLst/>
+          </a:prstGeom>
+          <a:noFill/>
+          <a:ln/>
+        </p:spPr>
+        <p:txBody>
+          <a:bodyPr wrap="square" lIns="0" tIns="0" rIns="0" bIns="0" rtlCol="0" anchor="ctr"/>
+          <a:lstStyle/>
+          <a:p>
+            <a:pPr indent="0" marL="0">
+              <a:buNone/>
+            </a:pPr>
+            <a:r>
+              <a:rPr lang="en-US" sz="1200" i="1" dirty="0">
+                <a:solidFill>
+                  <a:srgbClr val="8792AB"/>
+                </a:solidFill>
+                <a:latin typeface="Calibri" pitchFamily="34" charset="0"/>
+                <a:ea typeface="Calibri" pitchFamily="34" charset="-122"/>
+                <a:cs typeface="Calibri" pitchFamily="34" charset="-120"/>
+              </a:rPr>
+              <a:t>Start date to be defined at kick-off.</a:t>
+            </a:r>
+            <a:endParaRPr lang="en-US" sz="1200" dirty="0"/>
+          </a:p>
+        </p:txBody>
+      </p:sp>
+    </p:spTree>
+  </p:cSld>
+  <p:clrMapOvr>
+    <a:masterClrMapping/>
+  </p:clrMapOvr>
+</p:sld>
+</file>
+
+<file path=ppt/slides/slide11.xml><?xml version="1.0" encoding="utf-8"?>
+<p:sld xmlns:a="http://schemas.openxmlformats.org/drawingml/2006/main" xmlns:r="http://schemas.openxmlformats.org/officeDocument/2006/relationships" xmlns:p="http://schemas.openxmlformats.org/presentationml/2006/main">
+  <p:cSld name="Slide 11">
+    <p:bg>
+      <p:bgPr>
+        <a:solidFill>
           <a:srgbClr val="1E2761"/>
         </a:solidFill>
       </p:bgPr>
@@ -2699,6 +3761,27 @@
                 <a:cs typeface="Calibri" pitchFamily="34" charset="-120"/>
               </a:rPr>
               <a:t>Account ownership</a:t>
+            </a:r>
+            <a:endParaRPr lang="en-US" sz="1300" dirty="0"/>
+          </a:p>
+          <a:p>
+            <a:pPr marL="342900" indent="-342900">
+              <a:spcAft>
+                <a:spcPts val="1000"/>
+              </a:spcAft>
+              <a:buSzPct val="100000"/>
+              <a:buChar char="•"/>
+            </a:pPr>
+            <a:r>
+              <a:rPr lang="en-US" sz="1300" dirty="0">
+                <a:solidFill>
+                  <a:srgbClr val="CADCFC"/>
+                </a:solidFill>
+                <a:latin typeface="Calibri" pitchFamily="34" charset="0"/>
+                <a:ea typeface="Calibri" pitchFamily="34" charset="-122"/>
+                <a:cs typeface="Calibri" pitchFamily="34" charset="-120"/>
+              </a:rPr>
+              <a:t>Alliance priorities</a:t>
             </a:r>
             <a:endParaRPr lang="en-US" sz="1300" dirty="0"/>
           </a:p>
@@ -3538,7 +4621,7 @@
                 <a:ea typeface="Cambria" pitchFamily="34" charset="-122"/>
                 <a:cs typeface="Cambria" pitchFamily="34" charset="-120"/>
               </a:rPr>
-              <a:t>Seven questions to answer</a:t>
+              <a:t>Eight questions to answer</a:t>
             </a:r>
             <a:endParaRPr lang="en-US" sz="3600" dirty="0"/>
           </a:p>
@@ -4937,6 +6020,211 @@
       <p:sp>
         <p:nvSpPr>
           <p:cNvPr id="39" name="Shape 37"/>
+          <p:cNvSpPr/>
+          <p:nvPr/>
+        </p:nvSpPr>
+        <p:spPr>
+          <a:xfrm>
+            <a:off x="8869680" y="3794760"/>
+            <a:ext cx="2606040" cy="1783080"/>
+          </a:xfrm>
+          <a:prstGeom prst="roundRect">
+            <a:avLst>
+              <a:gd name="adj" fmla="val 6154"/>
+            </a:avLst>
+          </a:prstGeom>
+          <a:solidFill>
+            <a:srgbClr val="EDF2FA"/>
+          </a:solidFill>
+          <a:ln/>
+        </p:spPr>
+      </p:sp>
+      <p:sp>
+        <p:nvSpPr>
+          <p:cNvPr id="40" name="Shape 38"/>
+          <p:cNvSpPr/>
+          <p:nvPr/>
+        </p:nvSpPr>
+        <p:spPr>
+          <a:xfrm>
+            <a:off x="9098280" y="4050792"/>
+            <a:ext cx="365760" cy="365760"/>
+          </a:xfrm>
+          <a:prstGeom prst="ellipse">
+            <a:avLst/>
+          </a:prstGeom>
+          <a:solidFill>
+            <a:srgbClr val="1E2761"/>
+          </a:solidFill>
+          <a:ln/>
+        </p:spPr>
+      </p:sp>
+      <p:sp>
+        <p:nvSpPr>
+          <p:cNvPr id="41" name="Text 39"/>
+          <p:cNvSpPr txBox="1"/>
+          <p:nvPr/>
+        </p:nvSpPr>
+        <p:spPr>
+          <a:xfrm>
+            <a:off x="9098280" y="4050792"/>
+            <a:ext cx="365760" cy="365760"/>
+          </a:xfrm>
+          <a:prstGeom prst="rect">
+            <a:avLst/>
+          </a:prstGeom>
+          <a:noFill/>
+          <a:ln/>
+        </p:spPr>
+        <p:txBody>
+          <a:bodyPr wrap="square" lIns="0" tIns="0" rIns="0" bIns="0" rtlCol="0" anchor="ctr"/>
+          <a:lstStyle/>
+          <a:p>
+            <a:pPr algn="ctr" indent="0" marL="0">
+              <a:buNone/>
+            </a:pPr>
+            <a:r>
+              <a:rPr lang="en-US" sz="1200" b="1" dirty="0">
+                <a:solidFill>
+                  <a:srgbClr val="FFFFFF"/>
+                </a:solidFill>
+                <a:latin typeface="Calibri" pitchFamily="34" charset="0"/>
+                <a:ea typeface="Calibri" pitchFamily="34" charset="-122"/>
+                <a:cs typeface="Calibri" pitchFamily="34" charset="-120"/>
+              </a:rPr>
+              <a:t>8</a:t>
+            </a:r>
+            <a:endParaRPr lang="en-US" sz="1200" dirty="0"/>
+          </a:p>
+        </p:txBody>
+      </p:sp>
+      <p:sp>
+        <p:nvSpPr>
+          <p:cNvPr id="42" name="Text 40"/>
+          <p:cNvSpPr txBox="1"/>
+          <p:nvPr/>
+        </p:nvSpPr>
+        <p:spPr>
+          <a:xfrm>
+            <a:off x="9582912" y="4032504"/>
+            <a:ext cx="1783080" cy="365760"/>
+          </a:xfrm>
+          <a:prstGeom prst="rect">
+            <a:avLst/>
+          </a:prstGeom>
+          <a:noFill/>
+          <a:ln/>
+        </p:spPr>
+        <p:txBody>
+          <a:bodyPr wrap="square" lIns="0" tIns="0" rIns="0" bIns="0" rtlCol="0" anchor="ctr"/>
+          <a:lstStyle/>
+          <a:p>
+            <a:pPr indent="0" marL="0">
+              <a:buNone/>
+            </a:pPr>
+            <a:r>
+              <a:rPr lang="en-US" sz="1450" b="1" dirty="0">
+                <a:solidFill>
+                  <a:srgbClr val="16203A"/>
+                </a:solidFill>
+                <a:latin typeface="Calibri" pitchFamily="34" charset="0"/>
+                <a:ea typeface="Calibri" pitchFamily="34" charset="-122"/>
+                <a:cs typeface="Calibri" pitchFamily="34" charset="-120"/>
+              </a:rPr>
+              <a:t>Who we go with</a:t>
+            </a:r>
+            <a:endParaRPr lang="en-US" sz="1450" dirty="0"/>
+          </a:p>
+        </p:txBody>
+      </p:sp>
+      <p:sp>
+        <p:nvSpPr>
+          <p:cNvPr id="43" name="Text 41"/>
+          <p:cNvSpPr txBox="1"/>
+          <p:nvPr/>
+        </p:nvSpPr>
+        <p:spPr>
+          <a:xfrm>
+            <a:off x="9125712" y="4507992"/>
+            <a:ext cx="2194560" cy="960120"/>
+          </a:xfrm>
+          <a:prstGeom prst="rect">
+            <a:avLst/>
+          </a:prstGeom>
+          <a:noFill/>
+          <a:ln/>
+        </p:spPr>
+        <p:txBody>
+          <a:bodyPr wrap="square" lIns="0" tIns="0" rIns="0" bIns="0" rtlCol="0" anchor="ctr"/>
+          <a:lstStyle/>
+          <a:p>
+            <a:pPr marL="342900" indent="-342900">
+              <a:spcAft>
+                <a:spcPts val="400"/>
+              </a:spcAft>
+              <a:buSzPct val="100000"/>
+              <a:buChar char="•"/>
+            </a:pPr>
+            <a:r>
+              <a:rPr lang="en-US" sz="1050" dirty="0">
+                <a:solidFill>
+                  <a:srgbClr val="44506B"/>
+                </a:solidFill>
+                <a:latin typeface="Calibri" pitchFamily="34" charset="0"/>
+                <a:ea typeface="Calibri" pitchFamily="34" charset="-122"/>
+                <a:cs typeface="Calibri" pitchFamily="34" charset="-120"/>
+              </a:rPr>
+              <a:t>Which alliances matter for which offering?</a:t>
+            </a:r>
+            <a:endParaRPr lang="en-US" sz="1050" dirty="0"/>
+          </a:p>
+          <a:p>
+            <a:pPr marL="342900" indent="-342900">
+              <a:spcAft>
+                <a:spcPts val="400"/>
+              </a:spcAft>
+              <a:buSzPct val="100000"/>
+              <a:buChar char="•"/>
+            </a:pPr>
+            <a:r>
+              <a:rPr lang="en-US" sz="1050" dirty="0">
+                <a:solidFill>
+                  <a:srgbClr val="44506B"/>
+                </a:solidFill>
+                <a:latin typeface="Calibri" pitchFamily="34" charset="0"/>
+                <a:ea typeface="Calibri" pitchFamily="34" charset="-122"/>
+                <a:cs typeface="Calibri" pitchFamily="34" charset="-120"/>
+              </a:rPr>
+              <a:t>What do we leverage each one for?</a:t>
+            </a:r>
+            <a:endParaRPr lang="en-US" sz="1050" dirty="0"/>
+          </a:p>
+          <a:p>
+            <a:pPr marL="342900" indent="-342900">
+              <a:spcAft>
+                <a:spcPts val="400"/>
+              </a:spcAft>
+              <a:buSzPct val="100000"/>
+              <a:buChar char="•"/>
+            </a:pPr>
+            <a:r>
+              <a:rPr lang="en-US" sz="1050" dirty="0">
+                <a:solidFill>
+                  <a:srgbClr val="44506B"/>
+                </a:solidFill>
+                <a:latin typeface="Calibri" pitchFamily="34" charset="0"/>
+                <a:ea typeface="Calibri" pitchFamily="34" charset="-122"/>
+                <a:cs typeface="Calibri" pitchFamily="34" charset="-120"/>
+              </a:rPr>
+              <a:t>What do they expect back?</a:t>
+            </a:r>
+            <a:endParaRPr lang="en-US" sz="1050" dirty="0"/>
+          </a:p>
+        </p:txBody>
+      </p:sp>
+      <p:sp>
+        <p:nvSpPr>
+          <p:cNvPr id="44" name="Shape 42"/>
           <p:cNvSpPr/>
           <p:nvPr/>
         </p:nvSpPr>
@@ -4963,7 +6251,7 @@
       </p:sp>
       <p:sp>
         <p:nvSpPr>
-          <p:cNvPr id="40" name="Text 38"/>
+          <p:cNvPr id="45" name="Text 43"/>
           <p:cNvSpPr txBox="1"/>
           <p:nvPr/>
         </p:nvSpPr>
@@ -7263,7 +8551,7 @@
                 <a:ea typeface="Cambria" pitchFamily="34" charset="-122"/>
                 <a:cs typeface="Cambria" pitchFamily="34" charset="-120"/>
               </a:rPr>
-              <a:t>Seven workstreams, seven artefacts</a:t>
+              <a:t>Eight workstreams, eight artefacts</a:t>
             </a:r>
             <a:endParaRPr lang="en-US" sz="3600" dirty="0"/>
           </a:p>
@@ -7335,7 +8623,7 @@
                 <a:gridCol w="2377440"/>
                 <a:gridCol w="5486400"/>
               </a:tblGrid>
-              <a:tr h="438912">
+              <a:tr h="420624">
                 <a:tc>
                   <a:txBody>
                     <a:bodyPr/>
@@ -7345,7 +8633,7 @@
                         <a:buNone/>
                       </a:pPr>
                       <a:r>
-                        <a:rPr lang="en-US" sz="1200" b="1" dirty="0">
+                        <a:rPr lang="en-US" sz="1150" b="1" dirty="0">
                           <a:solidFill>
                             <a:srgbClr val="44506B"/>
                           </a:solidFill>
@@ -7355,14 +8643,14 @@
                         </a:rPr>
                         <a:t>Workstream</a:t>
                       </a:r>
-                      <a:endParaRPr lang="en-US" sz="1200" dirty="0">
+                      <a:endParaRPr lang="en-US" sz="1150" dirty="0">
                         <a:latin typeface="Calibri" charset="0"/>
                         <a:ea typeface="Calibri" charset="0"/>
                         <a:cs typeface="Calibri" charset="0"/>
                       </a:endParaRPr>
                     </a:p>
                   </a:txBody>
-                  <a:tcPr marL="88900" marR="88900" marT="88900" marB="88900" anchor="ctr">
+                  <a:tcPr marL="76200" marR="76200" marT="76200" marB="76200" anchor="ctr">
                     <a:lnL w="12700" cap="flat" cmpd="sng" algn="ctr">
                       <a:solidFill>
                         <a:srgbClr val="D8E0EE"/>
@@ -7413,7 +8701,7 @@
                         <a:buNone/>
                       </a:pPr>
                       <a:r>
-                        <a:rPr lang="en-US" sz="1200" b="1" dirty="0">
+                        <a:rPr lang="en-US" sz="1150" b="1" dirty="0">
                           <a:solidFill>
                             <a:srgbClr val="44506B"/>
                           </a:solidFill>
@@ -7423,14 +8711,14 @@
                         </a:rPr>
                         <a:t>Question it closes</a:t>
                       </a:r>
-                      <a:endParaRPr lang="en-US" sz="1200" dirty="0">
+                      <a:endParaRPr lang="en-US" sz="1150" dirty="0">
                         <a:latin typeface="Calibri" charset="0"/>
                         <a:ea typeface="Calibri" charset="0"/>
                         <a:cs typeface="Calibri" charset="0"/>
                       </a:endParaRPr>
                     </a:p>
                   </a:txBody>
-                  <a:tcPr marL="88900" marR="88900" marT="88900" marB="88900" anchor="ctr">
+                  <a:tcPr marL="76200" marR="76200" marT="76200" marB="76200" anchor="ctr">
                     <a:lnL w="12700" cap="flat" cmpd="sng" algn="ctr">
                       <a:solidFill>
                         <a:srgbClr val="D8E0EE"/>
@@ -7481,7 +8769,7 @@
                         <a:buNone/>
                       </a:pPr>
                       <a:r>
-                        <a:rPr lang="en-US" sz="1200" b="1" dirty="0">
+                        <a:rPr lang="en-US" sz="1150" b="1" dirty="0">
                           <a:solidFill>
                             <a:srgbClr val="44506B"/>
                           </a:solidFill>
@@ -7491,14 +8779,14 @@
                         </a:rPr>
                         <a:t>Artefact produced</a:t>
                       </a:r>
-                      <a:endParaRPr lang="en-US" sz="1200" dirty="0">
+                      <a:endParaRPr lang="en-US" sz="1150" dirty="0">
                         <a:latin typeface="Calibri" charset="0"/>
                         <a:ea typeface="Calibri" charset="0"/>
                         <a:cs typeface="Calibri" charset="0"/>
                       </a:endParaRPr>
                     </a:p>
                   </a:txBody>
-                  <a:tcPr marL="88900" marR="88900" marT="88900" marB="88900" anchor="ctr">
+                  <a:tcPr marL="76200" marR="76200" marT="76200" marB="76200" anchor="ctr">
                     <a:lnL w="12700" cap="flat" cmpd="sng" algn="ctr">
                       <a:solidFill>
                         <a:srgbClr val="D8E0EE"/>
@@ -7541,7 +8829,7 @@
                   </a:tcPr>
                 </a:tc>
               </a:tr>
-              <a:tr h="512064">
+              <a:tr h="457200">
                 <a:tc>
                   <a:txBody>
                     <a:bodyPr/>
@@ -7551,7 +8839,7 @@
                         <a:buNone/>
                       </a:pPr>
                       <a:r>
-                        <a:rPr lang="en-US" sz="1200" dirty="0">
+                        <a:rPr lang="en-US" sz="1150" dirty="0">
                           <a:solidFill>
                             <a:srgbClr val="44506B"/>
                           </a:solidFill>
@@ -7561,14 +8849,14 @@
                         </a:rPr>
                         <a:t>1 · Proposition &amp; catalogue</a:t>
                       </a:r>
-                      <a:endParaRPr lang="en-US" sz="1200" dirty="0">
+                      <a:endParaRPr lang="en-US" sz="1150" dirty="0">
                         <a:latin typeface="Calibri" charset="0"/>
                         <a:ea typeface="Calibri" charset="0"/>
                         <a:cs typeface="Calibri" charset="0"/>
                       </a:endParaRPr>
                     </a:p>
                   </a:txBody>
-                  <a:tcPr marL="88900" marR="88900" marT="88900" marB="88900" anchor="ctr">
+                  <a:tcPr marL="76200" marR="76200" marT="76200" marB="76200" anchor="ctr">
                     <a:lnL w="12700" cap="flat" cmpd="sng" algn="ctr">
                       <a:solidFill>
                         <a:srgbClr val="D8E0EE"/>
@@ -7619,7 +8907,7 @@
                         <a:buNone/>
                       </a:pPr>
                       <a:r>
-                        <a:rPr lang="en-US" sz="1200" dirty="0">
+                        <a:rPr lang="en-US" sz="1150" dirty="0">
                           <a:solidFill>
                             <a:srgbClr val="44506B"/>
                           </a:solidFill>
@@ -7629,14 +8917,14 @@
                         </a:rPr>
                         <a:t>What we offer</a:t>
                       </a:r>
-                      <a:endParaRPr lang="en-US" sz="1200" dirty="0">
+                      <a:endParaRPr lang="en-US" sz="1150" dirty="0">
                         <a:latin typeface="Calibri" charset="0"/>
                         <a:ea typeface="Calibri" charset="0"/>
                         <a:cs typeface="Calibri" charset="0"/>
                       </a:endParaRPr>
                     </a:p>
                   </a:txBody>
-                  <a:tcPr marL="88900" marR="88900" marT="88900" marB="88900" anchor="ctr">
+                  <a:tcPr marL="76200" marR="76200" marT="76200" marB="76200" anchor="ctr">
                     <a:lnL w="12700" cap="flat" cmpd="sng" algn="ctr">
                       <a:solidFill>
                         <a:srgbClr val="D8E0EE"/>
@@ -7687,7 +8975,7 @@
                         <a:buNone/>
                       </a:pPr>
                       <a:r>
-                        <a:rPr lang="en-US" sz="1200" dirty="0">
+                        <a:rPr lang="en-US" sz="1150" dirty="0">
                           <a:solidFill>
                             <a:srgbClr val="44506B"/>
                           </a:solidFill>
@@ -7697,14 +8985,14 @@
                         </a:rPr>
                         <a:t>Integrated proposition catalogue with permitted variants</a:t>
                       </a:r>
-                      <a:endParaRPr lang="en-US" sz="1200" dirty="0">
+                      <a:endParaRPr lang="en-US" sz="1150" dirty="0">
                         <a:latin typeface="Calibri" charset="0"/>
                         <a:ea typeface="Calibri" charset="0"/>
                         <a:cs typeface="Calibri" charset="0"/>
                       </a:endParaRPr>
                     </a:p>
                   </a:txBody>
-                  <a:tcPr marL="88900" marR="88900" marT="88900" marB="88900" anchor="ctr">
+                  <a:tcPr marL="76200" marR="76200" marT="76200" marB="76200" anchor="ctr">
                     <a:lnL w="12700" cap="flat" cmpd="sng" algn="ctr">
                       <a:solidFill>
                         <a:srgbClr val="D8E0EE"/>
@@ -7747,7 +9035,7 @@
                   </a:tcPr>
                 </a:tc>
               </a:tr>
-              <a:tr h="512064">
+              <a:tr h="457200">
                 <a:tc>
                   <a:txBody>
                     <a:bodyPr/>
@@ -7757,7 +9045,7 @@
                         <a:buNone/>
                       </a:pPr>
                       <a:r>
-                        <a:rPr lang="en-US" sz="1200" dirty="0">
+                        <a:rPr lang="en-US" sz="1150" dirty="0">
                           <a:solidFill>
                             <a:srgbClr val="44506B"/>
                           </a:solidFill>
@@ -7767,14 +9055,14 @@
                         </a:rPr>
                         <a:t>2 · Market &amp; account targeting</a:t>
                       </a:r>
-                      <a:endParaRPr lang="en-US" sz="1200" dirty="0">
+                      <a:endParaRPr lang="en-US" sz="1150" dirty="0">
                         <a:latin typeface="Calibri" charset="0"/>
                         <a:ea typeface="Calibri" charset="0"/>
                         <a:cs typeface="Calibri" charset="0"/>
                       </a:endParaRPr>
                     </a:p>
                   </a:txBody>
-                  <a:tcPr marL="88900" marR="88900" marT="88900" marB="88900" anchor="ctr">
+                  <a:tcPr marL="76200" marR="76200" marT="76200" marB="76200" anchor="ctr">
                     <a:lnL w="12700" cap="flat" cmpd="sng" algn="ctr">
                       <a:solidFill>
                         <a:srgbClr val="D8E0EE"/>
@@ -7825,7 +9113,7 @@
                         <a:buNone/>
                       </a:pPr>
                       <a:r>
-                        <a:rPr lang="en-US" sz="1200" dirty="0">
+                        <a:rPr lang="en-US" sz="1150" dirty="0">
                           <a:solidFill>
                             <a:srgbClr val="44506B"/>
                           </a:solidFill>
@@ -7835,14 +9123,14 @@
                         </a:rPr>
                         <a:t>Where to play</a:t>
                       </a:r>
-                      <a:endParaRPr lang="en-US" sz="1200" dirty="0">
+                      <a:endParaRPr lang="en-US" sz="1150" dirty="0">
                         <a:latin typeface="Calibri" charset="0"/>
                         <a:ea typeface="Calibri" charset="0"/>
                         <a:cs typeface="Calibri" charset="0"/>
                       </a:endParaRPr>
                     </a:p>
                   </a:txBody>
-                  <a:tcPr marL="88900" marR="88900" marT="88900" marB="88900" anchor="ctr">
+                  <a:tcPr marL="76200" marR="76200" marT="76200" marB="76200" anchor="ctr">
                     <a:lnL w="12700" cap="flat" cmpd="sng" algn="ctr">
                       <a:solidFill>
                         <a:srgbClr val="D8E0EE"/>
@@ -7893,7 +9181,7 @@
                         <a:buNone/>
                       </a:pPr>
                       <a:r>
-                        <a:rPr lang="en-US" sz="1200" dirty="0">
+                        <a:rPr lang="en-US" sz="1150" dirty="0">
                           <a:solidFill>
                             <a:srgbClr val="44506B"/>
                           </a:solidFill>
@@ -7903,14 +9191,14 @@
                         </a:rPr>
                         <a:t>Prioritised markets, segments and named account list</a:t>
                       </a:r>
-                      <a:endParaRPr lang="en-US" sz="1200" dirty="0">
+                      <a:endParaRPr lang="en-US" sz="1150" dirty="0">
                         <a:latin typeface="Calibri" charset="0"/>
                         <a:ea typeface="Calibri" charset="0"/>
                         <a:cs typeface="Calibri" charset="0"/>
                       </a:endParaRPr>
                     </a:p>
                   </a:txBody>
-                  <a:tcPr marL="88900" marR="88900" marT="88900" marB="88900" anchor="ctr">
+                  <a:tcPr marL="76200" marR="76200" marT="76200" marB="76200" anchor="ctr">
                     <a:lnL w="12700" cap="flat" cmpd="sng" algn="ctr">
                       <a:solidFill>
                         <a:srgbClr val="D8E0EE"/>
@@ -7953,7 +9241,7 @@
                   </a:tcPr>
                 </a:tc>
               </a:tr>
-              <a:tr h="512064">
+              <a:tr h="457200">
                 <a:tc>
                   <a:txBody>
                     <a:bodyPr/>
@@ -7963,7 +9251,7 @@
                         <a:buNone/>
                       </a:pPr>
                       <a:r>
-                        <a:rPr lang="en-US" sz="1200" dirty="0">
+                        <a:rPr lang="en-US" sz="1150" dirty="0">
                           <a:solidFill>
                             <a:srgbClr val="44506B"/>
                           </a:solidFill>
@@ -7973,14 +9261,14 @@
                         </a:rPr>
                         <a:t>3 · Commercial sizing &amp; pricing</a:t>
                       </a:r>
-                      <a:endParaRPr lang="en-US" sz="1200" dirty="0">
+                      <a:endParaRPr lang="en-US" sz="1150" dirty="0">
                         <a:latin typeface="Calibri" charset="0"/>
                         <a:ea typeface="Calibri" charset="0"/>
                         <a:cs typeface="Calibri" charset="0"/>
                       </a:endParaRPr>
                     </a:p>
                   </a:txBody>
-                  <a:tcPr marL="88900" marR="88900" marT="88900" marB="88900" anchor="ctr">
+                  <a:tcPr marL="76200" marR="76200" marT="76200" marB="76200" anchor="ctr">
                     <a:lnL w="12700" cap="flat" cmpd="sng" algn="ctr">
                       <a:solidFill>
                         <a:srgbClr val="D8E0EE"/>
@@ -8031,7 +9319,7 @@
                         <a:buNone/>
                       </a:pPr>
                       <a:r>
-                        <a:rPr lang="en-US" sz="1200" dirty="0">
+                        <a:rPr lang="en-US" sz="1150" dirty="0">
                           <a:solidFill>
                             <a:srgbClr val="44506B"/>
                           </a:solidFill>
@@ -8041,14 +9329,14 @@
                         </a:rPr>
                         <a:t>How much</a:t>
                       </a:r>
-                      <a:endParaRPr lang="en-US" sz="1200" dirty="0">
+                      <a:endParaRPr lang="en-US" sz="1150" dirty="0">
                         <a:latin typeface="Calibri" charset="0"/>
                         <a:ea typeface="Calibri" charset="0"/>
                         <a:cs typeface="Calibri" charset="0"/>
                       </a:endParaRPr>
                     </a:p>
                   </a:txBody>
-                  <a:tcPr marL="88900" marR="88900" marT="88900" marB="88900" anchor="ctr">
+                  <a:tcPr marL="76200" marR="76200" marT="76200" marB="76200" anchor="ctr">
                     <a:lnL w="12700" cap="flat" cmpd="sng" algn="ctr">
                       <a:solidFill>
                         <a:srgbClr val="D8E0EE"/>
@@ -8099,7 +9387,7 @@
                         <a:buNone/>
                       </a:pPr>
                       <a:r>
-                        <a:rPr lang="en-US" sz="1200" dirty="0">
+                        <a:rPr lang="en-US" sz="1150" dirty="0">
                           <a:solidFill>
                             <a:srgbClr val="44506B"/>
                           </a:solidFill>
@@ -8109,14 +9397,14 @@
                         </a:rPr>
                         <a:t>Deal-size bands, price benchmarks, revenue targets</a:t>
                       </a:r>
-                      <a:endParaRPr lang="en-US" sz="1200" dirty="0">
+                      <a:endParaRPr lang="en-US" sz="1150" dirty="0">
                         <a:latin typeface="Calibri" charset="0"/>
                         <a:ea typeface="Calibri" charset="0"/>
                         <a:cs typeface="Calibri" charset="0"/>
                       </a:endParaRPr>
                     </a:p>
                   </a:txBody>
-                  <a:tcPr marL="88900" marR="88900" marT="88900" marB="88900" anchor="ctr">
+                  <a:tcPr marL="76200" marR="76200" marT="76200" marB="76200" anchor="ctr">
                     <a:lnL w="12700" cap="flat" cmpd="sng" algn="ctr">
                       <a:solidFill>
                         <a:srgbClr val="D8E0EE"/>
@@ -8159,7 +9447,7 @@
                   </a:tcPr>
                 </a:tc>
               </a:tr>
-              <a:tr h="512064">
+              <a:tr h="457200">
                 <a:tc>
                   <a:txBody>
                     <a:bodyPr/>
@@ -8169,7 +9457,7 @@
                         <a:buNone/>
                       </a:pPr>
                       <a:r>
-                        <a:rPr lang="en-US" sz="1200" dirty="0">
+                        <a:rPr lang="en-US" sz="1150" dirty="0">
                           <a:solidFill>
                             <a:srgbClr val="44506B"/>
                           </a:solidFill>
@@ -8179,14 +9467,14 @@
                         </a:rPr>
                         <a:t>4 · Coverage &amp; ownership</a:t>
                       </a:r>
-                      <a:endParaRPr lang="en-US" sz="1200" dirty="0">
+                      <a:endParaRPr lang="en-US" sz="1150" dirty="0">
                         <a:latin typeface="Calibri" charset="0"/>
                         <a:ea typeface="Calibri" charset="0"/>
                         <a:cs typeface="Calibri" charset="0"/>
                       </a:endParaRPr>
                     </a:p>
                   </a:txBody>
-                  <a:tcPr marL="88900" marR="88900" marT="88900" marB="88900" anchor="ctr">
+                  <a:tcPr marL="76200" marR="76200" marT="76200" marB="76200" anchor="ctr">
                     <a:lnL w="12700" cap="flat" cmpd="sng" algn="ctr">
                       <a:solidFill>
                         <a:srgbClr val="D8E0EE"/>
@@ -8237,7 +9525,7 @@
                         <a:buNone/>
                       </a:pPr>
                       <a:r>
-                        <a:rPr lang="en-US" sz="1200" dirty="0">
+                        <a:rPr lang="en-US" sz="1150" dirty="0">
                           <a:solidFill>
                             <a:srgbClr val="44506B"/>
                           </a:solidFill>
@@ -8247,14 +9535,14 @@
                         </a:rPr>
                         <a:t>Who covers what</a:t>
                       </a:r>
-                      <a:endParaRPr lang="en-US" sz="1200" dirty="0">
+                      <a:endParaRPr lang="en-US" sz="1150" dirty="0">
                         <a:latin typeface="Calibri" charset="0"/>
                         <a:ea typeface="Calibri" charset="0"/>
                         <a:cs typeface="Calibri" charset="0"/>
                       </a:endParaRPr>
                     </a:p>
                   </a:txBody>
-                  <a:tcPr marL="88900" marR="88900" marT="88900" marB="88900" anchor="ctr">
+                  <a:tcPr marL="76200" marR="76200" marT="76200" marB="76200" anchor="ctr">
                     <a:lnL w="12700" cap="flat" cmpd="sng" algn="ctr">
                       <a:solidFill>
                         <a:srgbClr val="D8E0EE"/>
@@ -8305,7 +9593,7 @@
                         <a:buNone/>
                       </a:pPr>
                       <a:r>
-                        <a:rPr lang="en-US" sz="1200" dirty="0">
+                        <a:rPr lang="en-US" sz="1150" dirty="0">
                           <a:solidFill>
                             <a:srgbClr val="44506B"/>
                           </a:solidFill>
@@ -8315,14 +9603,14 @@
                         </a:rPr>
                         <a:t>Account-to-partner map and coverage model</a:t>
                       </a:r>
-                      <a:endParaRPr lang="en-US" sz="1200" dirty="0">
+                      <a:endParaRPr lang="en-US" sz="1150" dirty="0">
                         <a:latin typeface="Calibri" charset="0"/>
                         <a:ea typeface="Calibri" charset="0"/>
                         <a:cs typeface="Calibri" charset="0"/>
                       </a:endParaRPr>
                     </a:p>
                   </a:txBody>
-                  <a:tcPr marL="88900" marR="88900" marT="88900" marB="88900" anchor="ctr">
+                  <a:tcPr marL="76200" marR="76200" marT="76200" marB="76200" anchor="ctr">
                     <a:lnL w="12700" cap="flat" cmpd="sng" algn="ctr">
                       <a:solidFill>
                         <a:srgbClr val="D8E0EE"/>
@@ -8365,7 +9653,7 @@
                   </a:tcPr>
                 </a:tc>
               </a:tr>
-              <a:tr h="512064">
+              <a:tr h="457200">
                 <a:tc>
                   <a:txBody>
                     <a:bodyPr/>
@@ -8375,7 +9663,7 @@
                         <a:buNone/>
                       </a:pPr>
                       <a:r>
-                        <a:rPr lang="en-US" sz="1200" dirty="0">
+                        <a:rPr lang="en-US" sz="1150" dirty="0">
                           <a:solidFill>
                             <a:srgbClr val="44506B"/>
                           </a:solidFill>
@@ -8385,14 +9673,14 @@
                         </a:rPr>
                         <a:t>5 · Delivery model &amp; readiness</a:t>
                       </a:r>
-                      <a:endParaRPr lang="en-US" sz="1200" dirty="0">
+                      <a:endParaRPr lang="en-US" sz="1150" dirty="0">
                         <a:latin typeface="Calibri" charset="0"/>
                         <a:ea typeface="Calibri" charset="0"/>
                         <a:cs typeface="Calibri" charset="0"/>
                       </a:endParaRPr>
                     </a:p>
                   </a:txBody>
-                  <a:tcPr marL="88900" marR="88900" marT="88900" marB="88900" anchor="ctr">
+                  <a:tcPr marL="76200" marR="76200" marT="76200" marB="76200" anchor="ctr">
                     <a:lnL w="12700" cap="flat" cmpd="sng" algn="ctr">
                       <a:solidFill>
                         <a:srgbClr val="D8E0EE"/>
@@ -8443,7 +9731,7 @@
                         <a:buNone/>
                       </a:pPr>
                       <a:r>
-                        <a:rPr lang="en-US" sz="1200" dirty="0">
+                        <a:rPr lang="en-US" sz="1150" dirty="0">
                           <a:solidFill>
                             <a:srgbClr val="44506B"/>
                           </a:solidFill>
@@ -8453,14 +9741,14 @@
                         </a:rPr>
                         <a:t>How we win</a:t>
                       </a:r>
-                      <a:endParaRPr lang="en-US" sz="1200" dirty="0">
+                      <a:endParaRPr lang="en-US" sz="1150" dirty="0">
                         <a:latin typeface="Calibri" charset="0"/>
                         <a:ea typeface="Calibri" charset="0"/>
                         <a:cs typeface="Calibri" charset="0"/>
                       </a:endParaRPr>
                     </a:p>
                   </a:txBody>
-                  <a:tcPr marL="88900" marR="88900" marT="88900" marB="88900" anchor="ctr">
+                  <a:tcPr marL="76200" marR="76200" marT="76200" marB="76200" anchor="ctr">
                     <a:lnL w="12700" cap="flat" cmpd="sng" algn="ctr">
                       <a:solidFill>
                         <a:srgbClr val="D8E0EE"/>
@@ -8511,7 +9799,7 @@
                         <a:buNone/>
                       </a:pPr>
                       <a:r>
-                        <a:rPr lang="en-US" sz="1200" dirty="0">
+                        <a:rPr lang="en-US" sz="1150" dirty="0">
                           <a:solidFill>
                             <a:srgbClr val="44506B"/>
                           </a:solidFill>
@@ -8521,14 +9809,14 @@
                         </a:rPr>
                         <a:t>Delivery approach and delivery standards</a:t>
                       </a:r>
-                      <a:endParaRPr lang="en-US" sz="1200" dirty="0">
+                      <a:endParaRPr lang="en-US" sz="1150" dirty="0">
                         <a:latin typeface="Calibri" charset="0"/>
                         <a:ea typeface="Calibri" charset="0"/>
                         <a:cs typeface="Calibri" charset="0"/>
                       </a:endParaRPr>
                     </a:p>
                   </a:txBody>
-                  <a:tcPr marL="88900" marR="88900" marT="88900" marB="88900" anchor="ctr">
+                  <a:tcPr marL="76200" marR="76200" marT="76200" marB="76200" anchor="ctr">
                     <a:lnL w="12700" cap="flat" cmpd="sng" algn="ctr">
                       <a:solidFill>
                         <a:srgbClr val="D8E0EE"/>
@@ -8571,7 +9859,7 @@
                   </a:tcPr>
                 </a:tc>
               </a:tr>
-              <a:tr h="512064">
+              <a:tr h="457200">
                 <a:tc>
                   <a:txBody>
                     <a:bodyPr/>
@@ -8581,7 +9869,7 @@
                         <a:buNone/>
                       </a:pPr>
                       <a:r>
-                        <a:rPr lang="en-US" sz="1200" dirty="0">
+                        <a:rPr lang="en-US" sz="1150" dirty="0">
                           <a:solidFill>
                             <a:srgbClr val="44506B"/>
                           </a:solidFill>
@@ -8591,14 +9879,14 @@
                         </a:rPr>
                         <a:t>6 · Team &amp; talent</a:t>
                       </a:r>
-                      <a:endParaRPr lang="en-US" sz="1200" dirty="0">
+                      <a:endParaRPr lang="en-US" sz="1150" dirty="0">
                         <a:latin typeface="Calibri" charset="0"/>
                         <a:ea typeface="Calibri" charset="0"/>
                         <a:cs typeface="Calibri" charset="0"/>
                       </a:endParaRPr>
                     </a:p>
                   </a:txBody>
-                  <a:tcPr marL="88900" marR="88900" marT="88900" marB="88900" anchor="ctr">
+                  <a:tcPr marL="76200" marR="76200" marT="76200" marB="76200" anchor="ctr">
                     <a:lnL w="12700" cap="flat" cmpd="sng" algn="ctr">
                       <a:solidFill>
                         <a:srgbClr val="D8E0EE"/>
@@ -8649,7 +9937,7 @@
                         <a:buNone/>
                       </a:pPr>
                       <a:r>
-                        <a:rPr lang="en-US" sz="1200" dirty="0">
+                        <a:rPr lang="en-US" sz="1150" dirty="0">
                           <a:solidFill>
                             <a:srgbClr val="44506B"/>
                           </a:solidFill>
@@ -8659,14 +9947,14 @@
                         </a:rPr>
                         <a:t>Who delivers it</a:t>
                       </a:r>
-                      <a:endParaRPr lang="en-US" sz="1200" dirty="0">
+                      <a:endParaRPr lang="en-US" sz="1150" dirty="0">
                         <a:latin typeface="Calibri" charset="0"/>
                         <a:ea typeface="Calibri" charset="0"/>
                         <a:cs typeface="Calibri" charset="0"/>
                       </a:endParaRPr>
                     </a:p>
                   </a:txBody>
-                  <a:tcPr marL="88900" marR="88900" marT="88900" marB="88900" anchor="ctr">
+                  <a:tcPr marL="76200" marR="76200" marT="76200" marB="76200" anchor="ctr">
                     <a:lnL w="12700" cap="flat" cmpd="sng" algn="ctr">
                       <a:solidFill>
                         <a:srgbClr val="D8E0EE"/>
@@ -8717,7 +10005,7 @@
                         <a:buNone/>
                       </a:pPr>
                       <a:r>
-                        <a:rPr lang="en-US" sz="1200" dirty="0">
+                        <a:rPr lang="en-US" sz="1150" dirty="0">
                           <a:solidFill>
                             <a:srgbClr val="44506B"/>
                           </a:solidFill>
@@ -8727,14 +10015,14 @@
                         </a:rPr>
                         <a:t>Dedicated FSI team, shared capacity view, recruitment plan</a:t>
                       </a:r>
-                      <a:endParaRPr lang="en-US" sz="1200" dirty="0">
+                      <a:endParaRPr lang="en-US" sz="1150" dirty="0">
                         <a:latin typeface="Calibri" charset="0"/>
                         <a:ea typeface="Calibri" charset="0"/>
                         <a:cs typeface="Calibri" charset="0"/>
                       </a:endParaRPr>
                     </a:p>
                   </a:txBody>
-                  <a:tcPr marL="88900" marR="88900" marT="88900" marB="88900" anchor="ctr">
+                  <a:tcPr marL="76200" marR="76200" marT="76200" marB="76200" anchor="ctr">
                     <a:lnL w="12700" cap="flat" cmpd="sng" algn="ctr">
                       <a:solidFill>
                         <a:srgbClr val="D8E0EE"/>
@@ -8777,7 +10065,7 @@
                   </a:tcPr>
                 </a:tc>
               </a:tr>
-              <a:tr h="512064">
+              <a:tr h="457200">
                 <a:tc>
                   <a:txBody>
                     <a:bodyPr/>
@@ -8787,7 +10075,7 @@
                         <a:buNone/>
                       </a:pPr>
                       <a:r>
-                        <a:rPr lang="en-US" sz="1200" dirty="0">
+                        <a:rPr lang="en-US" sz="1150" dirty="0">
                           <a:solidFill>
                             <a:srgbClr val="44506B"/>
                           </a:solidFill>
@@ -8797,14 +10085,14 @@
                         </a:rPr>
                         <a:t>7 · Eminence &amp; positioning</a:t>
                       </a:r>
-                      <a:endParaRPr lang="en-US" sz="1200" dirty="0">
+                      <a:endParaRPr lang="en-US" sz="1150" dirty="0">
                         <a:latin typeface="Calibri" charset="0"/>
                         <a:ea typeface="Calibri" charset="0"/>
                         <a:cs typeface="Calibri" charset="0"/>
                       </a:endParaRPr>
                     </a:p>
                   </a:txBody>
-                  <a:tcPr marL="88900" marR="88900" marT="88900" marB="88900" anchor="ctr">
+                  <a:tcPr marL="76200" marR="76200" marT="76200" marB="76200" anchor="ctr">
                     <a:lnL w="12700" cap="flat" cmpd="sng" algn="ctr">
                       <a:solidFill>
                         <a:srgbClr val="D8E0EE"/>
@@ -8855,7 +10143,7 @@
                         <a:buNone/>
                       </a:pPr>
                       <a:r>
-                        <a:rPr lang="en-US" sz="1200" dirty="0">
+                        <a:rPr lang="en-US" sz="1150" dirty="0">
                           <a:solidFill>
                             <a:srgbClr val="44506B"/>
                           </a:solidFill>
@@ -8865,14 +10153,14 @@
                         </a:rPr>
                         <a:t>How we are known</a:t>
                       </a:r>
-                      <a:endParaRPr lang="en-US" sz="1200" dirty="0">
+                      <a:endParaRPr lang="en-US" sz="1150" dirty="0">
                         <a:latin typeface="Calibri" charset="0"/>
                         <a:ea typeface="Calibri" charset="0"/>
                         <a:cs typeface="Calibri" charset="0"/>
                       </a:endParaRPr>
                     </a:p>
                   </a:txBody>
-                  <a:tcPr marL="88900" marR="88900" marT="88900" marB="88900" anchor="ctr">
+                  <a:tcPr marL="76200" marR="76200" marT="76200" marB="76200" anchor="ctr">
                     <a:lnL w="12700" cap="flat" cmpd="sng" algn="ctr">
                       <a:solidFill>
                         <a:srgbClr val="D8E0EE"/>
@@ -8923,7 +10211,7 @@
                         <a:buNone/>
                       </a:pPr>
                       <a:r>
-                        <a:rPr lang="en-US" sz="1200" dirty="0">
+                        <a:rPr lang="en-US" sz="1150" dirty="0">
                           <a:solidFill>
                             <a:srgbClr val="44506B"/>
                           </a:solidFill>
@@ -8933,14 +10221,220 @@
                         </a:rPr>
                         <a:t>Eminence plan: content, events and speaking calendar</a:t>
                       </a:r>
-                      <a:endParaRPr lang="en-US" sz="1200" dirty="0">
+                      <a:endParaRPr lang="en-US" sz="1150" dirty="0">
                         <a:latin typeface="Calibri" charset="0"/>
                         <a:ea typeface="Calibri" charset="0"/>
                         <a:cs typeface="Calibri" charset="0"/>
                       </a:endParaRPr>
                     </a:p>
                   </a:txBody>
-                  <a:tcPr marL="88900" marR="88900" marT="88900" marB="88900" anchor="ctr">
+                  <a:tcPr marL="76200" marR="76200" marT="76200" marB="76200" anchor="ctr">
+                    <a:lnL w="12700" cap="flat" cmpd="sng" algn="ctr">
+                      <a:solidFill>
+                        <a:srgbClr val="D8E0EE"/>
+                      </a:solidFill>
+                      <a:prstDash val="solid"/>
+                      <a:round/>
+                      <a:headEnd type="none" w="med" len="med"/>
+                      <a:tailEnd type="none" w="med" len="med"/>
+                    </a:lnL>
+                    <a:lnR w="12700" cap="flat" cmpd="sng" algn="ctr">
+                      <a:solidFill>
+                        <a:srgbClr val="D8E0EE"/>
+                      </a:solidFill>
+                      <a:prstDash val="solid"/>
+                      <a:round/>
+                      <a:headEnd type="none" w="med" len="med"/>
+                      <a:tailEnd type="none" w="med" len="med"/>
+                    </a:lnR>
+                    <a:lnT w="12700" cap="flat" cmpd="sng" algn="ctr">
+                      <a:solidFill>
+                        <a:srgbClr val="D8E0EE"/>
+                      </a:solidFill>
+                      <a:prstDash val="solid"/>
+                      <a:round/>
+                      <a:headEnd type="none" w="med" len="med"/>
+                      <a:tailEnd type="none" w="med" len="med"/>
+                    </a:lnT>
+                    <a:lnB w="12700" cap="flat" cmpd="sng" algn="ctr">
+                      <a:solidFill>
+                        <a:srgbClr val="D8E0EE"/>
+                      </a:solidFill>
+                      <a:prstDash val="solid"/>
+                      <a:round/>
+                      <a:headEnd type="none" w="med" len="med"/>
+                      <a:tailEnd type="none" w="med" len="med"/>
+                    </a:lnB>
+                    <a:solidFill>
+                      <a:srgbClr val="FFFFFF"/>
+                    </a:solidFill>
+                  </a:tcPr>
+                </a:tc>
+              </a:tr>
+              <a:tr h="457200">
+                <a:tc>
+                  <a:txBody>
+                    <a:bodyPr/>
+                    <a:lstStyle/>
+                    <a:p>
+                      <a:pPr algn="l" indent="0" marL="0">
+                        <a:buNone/>
+                      </a:pPr>
+                      <a:r>
+                        <a:rPr lang="en-US" sz="1150" dirty="0">
+                          <a:solidFill>
+                            <a:srgbClr val="44506B"/>
+                          </a:solidFill>
+                          <a:latin typeface="Calibri" pitchFamily="34" charset="0"/>
+                          <a:ea typeface="Calibri" pitchFamily="34" charset="-122"/>
+                          <a:cs typeface="Calibri" pitchFamily="34" charset="-120"/>
+                        </a:rPr>
+                        <a:t>8 · Alliances</a:t>
+                      </a:r>
+                      <a:endParaRPr lang="en-US" sz="1150" dirty="0">
+                        <a:latin typeface="Calibri" charset="0"/>
+                        <a:ea typeface="Calibri" charset="0"/>
+                        <a:cs typeface="Calibri" charset="0"/>
+                      </a:endParaRPr>
+                    </a:p>
+                  </a:txBody>
+                  <a:tcPr marL="76200" marR="76200" marT="76200" marB="76200" anchor="ctr">
+                    <a:lnL w="12700" cap="flat" cmpd="sng" algn="ctr">
+                      <a:solidFill>
+                        <a:srgbClr val="D8E0EE"/>
+                      </a:solidFill>
+                      <a:prstDash val="solid"/>
+                      <a:round/>
+                      <a:headEnd type="none" w="med" len="med"/>
+                      <a:tailEnd type="none" w="med" len="med"/>
+                    </a:lnL>
+                    <a:lnR w="12700" cap="flat" cmpd="sng" algn="ctr">
+                      <a:solidFill>
+                        <a:srgbClr val="D8E0EE"/>
+                      </a:solidFill>
+                      <a:prstDash val="solid"/>
+                      <a:round/>
+                      <a:headEnd type="none" w="med" len="med"/>
+                      <a:tailEnd type="none" w="med" len="med"/>
+                    </a:lnR>
+                    <a:lnT w="12700" cap="flat" cmpd="sng" algn="ctr">
+                      <a:solidFill>
+                        <a:srgbClr val="D8E0EE"/>
+                      </a:solidFill>
+                      <a:prstDash val="solid"/>
+                      <a:round/>
+                      <a:headEnd type="none" w="med" len="med"/>
+                      <a:tailEnd type="none" w="med" len="med"/>
+                    </a:lnT>
+                    <a:lnB w="12700" cap="flat" cmpd="sng" algn="ctr">
+                      <a:solidFill>
+                        <a:srgbClr val="D8E0EE"/>
+                      </a:solidFill>
+                      <a:prstDash val="solid"/>
+                      <a:round/>
+                      <a:headEnd type="none" w="med" len="med"/>
+                      <a:tailEnd type="none" w="med" len="med"/>
+                    </a:lnB>
+                    <a:solidFill>
+                      <a:srgbClr val="FFFFFF"/>
+                    </a:solidFill>
+                  </a:tcPr>
+                </a:tc>
+                <a:tc>
+                  <a:txBody>
+                    <a:bodyPr/>
+                    <a:lstStyle/>
+                    <a:p>
+                      <a:pPr algn="l" indent="0" marL="0">
+                        <a:buNone/>
+                      </a:pPr>
+                      <a:r>
+                        <a:rPr lang="en-US" sz="1150" dirty="0">
+                          <a:solidFill>
+                            <a:srgbClr val="44506B"/>
+                          </a:solidFill>
+                          <a:latin typeface="Calibri" pitchFamily="34" charset="0"/>
+                          <a:ea typeface="Calibri" pitchFamily="34" charset="-122"/>
+                          <a:cs typeface="Calibri" pitchFamily="34" charset="-120"/>
+                        </a:rPr>
+                        <a:t>Who we go with</a:t>
+                      </a:r>
+                      <a:endParaRPr lang="en-US" sz="1150" dirty="0">
+                        <a:latin typeface="Calibri" charset="0"/>
+                        <a:ea typeface="Calibri" charset="0"/>
+                        <a:cs typeface="Calibri" charset="0"/>
+                      </a:endParaRPr>
+                    </a:p>
+                  </a:txBody>
+                  <a:tcPr marL="76200" marR="76200" marT="76200" marB="76200" anchor="ctr">
+                    <a:lnL w="12700" cap="flat" cmpd="sng" algn="ctr">
+                      <a:solidFill>
+                        <a:srgbClr val="D8E0EE"/>
+                      </a:solidFill>
+                      <a:prstDash val="solid"/>
+                      <a:round/>
+                      <a:headEnd type="none" w="med" len="med"/>
+                      <a:tailEnd type="none" w="med" len="med"/>
+                    </a:lnL>
+                    <a:lnR w="12700" cap="flat" cmpd="sng" algn="ctr">
+                      <a:solidFill>
+                        <a:srgbClr val="D8E0EE"/>
+                      </a:solidFill>
+                      <a:prstDash val="solid"/>
+                      <a:round/>
+                      <a:headEnd type="none" w="med" len="med"/>
+                      <a:tailEnd type="none" w="med" len="med"/>
+                    </a:lnR>
+                    <a:lnT w="12700" cap="flat" cmpd="sng" algn="ctr">
+                      <a:solidFill>
+                        <a:srgbClr val="D8E0EE"/>
+                      </a:solidFill>
+                      <a:prstDash val="solid"/>
+                      <a:round/>
+                      <a:headEnd type="none" w="med" len="med"/>
+                      <a:tailEnd type="none" w="med" len="med"/>
+                    </a:lnT>
+                    <a:lnB w="12700" cap="flat" cmpd="sng" algn="ctr">
+                      <a:solidFill>
+                        <a:srgbClr val="D8E0EE"/>
+                      </a:solidFill>
+                      <a:prstDash val="solid"/>
+                      <a:round/>
+                      <a:headEnd type="none" w="med" len="med"/>
+                      <a:tailEnd type="none" w="med" len="med"/>
+                    </a:lnB>
+                    <a:solidFill>
+                      <a:srgbClr val="FFFFFF"/>
+                    </a:solidFill>
+                  </a:tcPr>
+                </a:tc>
+                <a:tc>
+                  <a:txBody>
+                    <a:bodyPr/>
+                    <a:lstStyle/>
+                    <a:p>
+                      <a:pPr algn="l" indent="0" marL="0">
+                        <a:buNone/>
+                      </a:pPr>
+                      <a:r>
+                        <a:rPr lang="en-US" sz="1150" dirty="0">
+                          <a:solidFill>
+                            <a:srgbClr val="44506B"/>
+                          </a:solidFill>
+                          <a:latin typeface="Calibri" pitchFamily="34" charset="0"/>
+                          <a:ea typeface="Calibri" pitchFamily="34" charset="-122"/>
+                          <a:cs typeface="Calibri" pitchFamily="34" charset="-120"/>
+                        </a:rPr>
+                        <a:t>Alliance map: role, offerings and accounts per partner</a:t>
+                      </a:r>
+                      <a:endParaRPr lang="en-US" sz="1150" dirty="0">
+                        <a:latin typeface="Calibri" charset="0"/>
+                        <a:ea typeface="Calibri" charset="0"/>
+                        <a:cs typeface="Calibri" charset="0"/>
+                      </a:endParaRPr>
+                    </a:p>
+                  </a:txBody>
+                  <a:tcPr marL="76200" marR="76200" marT="76200" marB="76200" anchor="ctr">
                     <a:lnL w="12700" cap="flat" cmpd="sng" algn="ctr">
                       <a:solidFill>
                         <a:srgbClr val="D8E0EE"/>
@@ -9132,7 +10626,7 @@
         </p:nvSpPr>
         <p:spPr>
           <a:xfrm>
-            <a:off x="640080" y="5897880"/>
+            <a:off x="640080" y="6035040"/>
             <a:ext cx="10881360" cy="365760"/>
           </a:xfrm>
           <a:prstGeom prst="rect">
@@ -9149,7 +10643,7 @@
               <a:buNone/>
             </a:pPr>
             <a:r>
-              <a:rPr lang="en-US" sz="1300" i="1" dirty="0">
+              <a:rPr lang="en-US" sz="1250" i="1" dirty="0">
                 <a:solidFill>
                   <a:srgbClr val="8792AB"/>
                 </a:solidFill>
@@ -9159,7 +10653,7 @@
               </a:rPr>
               <a:t>Workstreams run in parallel; dependencies are resolved at the weekly checkpoint.</a:t>
             </a:r>
-            <a:endParaRPr lang="en-US" sz="1300" dirty="0"/>
+            <a:endParaRPr lang="en-US" sz="1250" dirty="0"/>
           </a:p>
         </p:txBody>
       </p:sp>
@@ -11203,7 +12697,7 @@
                 <a:ea typeface="Cambria" pitchFamily="34" charset="-122"/>
                 <a:cs typeface="Cambria" pitchFamily="34" charset="-120"/>
               </a:rPr>
-              <a:t>The three-week journey</a:t>
+              <a:t>Alliances</a:t>
             </a:r>
             <a:endParaRPr lang="en-US" sz="3600" dirty="0"/>
           </a:p>
@@ -11242,7 +12736,7 @@
                 <a:ea typeface="Calibri" pitchFamily="34" charset="-122"/>
                 <a:cs typeface="Calibri" pitchFamily="34" charset="-120"/>
               </a:rPr>
-              <a:t>Three weeks, three gates, one decision.</a:t>
+              <a:t>Who we go to market with, and what we use each one for.</a:t>
             </a:r>
             <a:endParaRPr lang="en-US" sz="1450" dirty="0"/>
           </a:p>
@@ -11257,11 +12751,11 @@
         <p:spPr>
           <a:xfrm>
             <a:off x="640080" y="1828800"/>
-            <a:ext cx="3429000" cy="3840480"/>
+            <a:ext cx="5120640" cy="2057400"/>
           </a:xfrm>
           <a:prstGeom prst="roundRect">
             <a:avLst>
-              <a:gd name="adj" fmla="val 3200"/>
+              <a:gd name="adj" fmla="val 5333"/>
             </a:avLst>
           </a:prstGeom>
           <a:solidFill>
@@ -11272,17 +12766,58 @@
       </p:sp>
       <p:sp>
         <p:nvSpPr>
-          <p:cNvPr id="5" name="Shape 3"/>
+          <p:cNvPr id="5" name="Text 3"/>
+          <p:cNvSpPr txBox="1"/>
+          <p:nvPr/>
+        </p:nvSpPr>
+        <p:spPr>
+          <a:xfrm>
+            <a:off x="914400" y="1965960"/>
+            <a:ext cx="4572000" cy="365760"/>
+          </a:xfrm>
+          <a:prstGeom prst="rect">
+            <a:avLst/>
+          </a:prstGeom>
+          <a:noFill/>
+          <a:ln/>
+        </p:spPr>
+        <p:txBody>
+          <a:bodyPr wrap="square" lIns="0" tIns="0" rIns="0" bIns="0" rtlCol="0" anchor="ctr"/>
+          <a:lstStyle/>
+          <a:p>
+            <a:pPr indent="0" marL="0">
+              <a:buNone/>
+            </a:pPr>
+            <a:r>
+              <a:rPr lang="en-US" sz="1700" b="1" dirty="0">
+                <a:solidFill>
+                  <a:srgbClr val="1E2761"/>
+                </a:solidFill>
+                <a:latin typeface="Calibri" pitchFamily="34" charset="0"/>
+                <a:ea typeface="Calibri" pitchFamily="34" charset="-122"/>
+                <a:cs typeface="Calibri" pitchFamily="34" charset="-120"/>
+              </a:rPr>
+              <a:t>Primary alliances</a:t>
+            </a:r>
+            <a:endParaRPr lang="en-US" sz="1700" dirty="0"/>
+          </a:p>
+        </p:txBody>
+      </p:sp>
+      <p:sp>
+        <p:nvSpPr>
+          <p:cNvPr id="6" name="Shape 4"/>
           <p:cNvSpPr/>
           <p:nvPr/>
         </p:nvSpPr>
         <p:spPr>
           <a:xfrm>
-            <a:off x="640080" y="1828800"/>
-            <a:ext cx="3429000" cy="685800"/>
-          </a:xfrm>
-          <a:prstGeom prst="rect">
-            <a:avLst/>
+            <a:off x="914400" y="2468880"/>
+            <a:ext cx="1402080" cy="1051560"/>
+          </a:xfrm>
+          <a:prstGeom prst="roundRect">
+            <a:avLst>
+              <a:gd name="adj" fmla="val 8696"/>
+            </a:avLst>
           </a:prstGeom>
           <a:solidFill>
             <a:srgbClr val="1E2761"/>
@@ -11292,219 +12827,14 @@
       </p:sp>
       <p:sp>
         <p:nvSpPr>
-          <p:cNvPr id="6" name="Text 4"/>
-          <p:cNvSpPr txBox="1"/>
-          <p:nvPr/>
-        </p:nvSpPr>
-        <p:spPr>
-          <a:xfrm>
-            <a:off x="914400" y="1828800"/>
-            <a:ext cx="2926080" cy="685800"/>
-          </a:xfrm>
-          <a:prstGeom prst="rect">
-            <a:avLst/>
-          </a:prstGeom>
-          <a:noFill/>
-          <a:ln/>
-        </p:spPr>
-        <p:txBody>
-          <a:bodyPr wrap="square" lIns="0" tIns="0" rIns="0" bIns="0" rtlCol="0" anchor="ctr"/>
-          <a:lstStyle/>
-          <a:p>
-            <a:pPr indent="0" marL="0">
-              <a:buNone/>
-            </a:pPr>
-            <a:r>
-              <a:rPr lang="en-US" sz="1800" b="1" dirty="0">
-                <a:solidFill>
-                  <a:srgbClr val="FFFFFF"/>
-                </a:solidFill>
-                <a:latin typeface="Calibri" pitchFamily="34" charset="0"/>
-                <a:ea typeface="Calibri" pitchFamily="34" charset="-122"/>
-                <a:cs typeface="Calibri" pitchFamily="34" charset="-120"/>
-              </a:rPr>
-              <a:t>Week 1  ·  Frame</a:t>
-            </a:r>
-            <a:endParaRPr lang="en-US" sz="1800" dirty="0"/>
-          </a:p>
-        </p:txBody>
-      </p:sp>
-      <p:sp>
-        <p:nvSpPr>
           <p:cNvPr id="7" name="Text 5"/>
           <p:cNvSpPr txBox="1"/>
           <p:nvPr/>
         </p:nvSpPr>
         <p:spPr>
           <a:xfrm>
-            <a:off x="914400" y="2743200"/>
-            <a:ext cx="2880360" cy="1920240"/>
-          </a:xfrm>
-          <a:prstGeom prst="rect">
-            <a:avLst/>
-          </a:prstGeom>
-          <a:noFill/>
-          <a:ln/>
-        </p:spPr>
-        <p:txBody>
-          <a:bodyPr wrap="square" lIns="0" tIns="0" rIns="0" bIns="0" rtlCol="0" anchor="ctr"/>
-          <a:lstStyle/>
-          <a:p>
-            <a:pPr marL="342900" indent="-342900">
-              <a:spcAft>
-                <a:spcPts val="900"/>
-              </a:spcAft>
-              <a:buSzPct val="100000"/>
-              <a:buChar char="•"/>
-            </a:pPr>
-            <a:r>
-              <a:rPr lang="en-US" sz="1250" dirty="0">
-                <a:solidFill>
-                  <a:srgbClr val="44506B"/>
-                </a:solidFill>
-                <a:latin typeface="Calibri" pitchFamily="34" charset="0"/>
-                <a:ea typeface="Calibri" pitchFamily="34" charset="-122"/>
-                <a:cs typeface="Calibri" pitchFamily="34" charset="-120"/>
-              </a:rPr>
-              <a:t>Baseline current position and credentials</a:t>
-            </a:r>
-            <a:endParaRPr lang="en-US" sz="1250" dirty="0"/>
-          </a:p>
-          <a:p>
-            <a:pPr marL="342900" indent="-342900">
-              <a:spcAft>
-                <a:spcPts val="900"/>
-              </a:spcAft>
-              <a:buSzPct val="100000"/>
-              <a:buChar char="•"/>
-            </a:pPr>
-            <a:r>
-              <a:rPr lang="en-US" sz="1250" dirty="0">
-                <a:solidFill>
-                  <a:srgbClr val="44506B"/>
-                </a:solidFill>
-                <a:latin typeface="Calibri" pitchFamily="34" charset="0"/>
-                <a:ea typeface="Calibri" pitchFamily="34" charset="-122"/>
-                <a:cs typeface="Calibri" pitchFamily="34" charset="-120"/>
-              </a:rPr>
-              <a:t>Prioritise markets and segments</a:t>
-            </a:r>
-            <a:endParaRPr lang="en-US" sz="1250" dirty="0"/>
-          </a:p>
-          <a:p>
-            <a:pPr marL="342900" indent="-342900">
-              <a:spcAft>
-                <a:spcPts val="900"/>
-              </a:spcAft>
-              <a:buSzPct val="100000"/>
-              <a:buChar char="•"/>
-            </a:pPr>
-            <a:r>
-              <a:rPr lang="en-US" sz="1250" dirty="0">
-                <a:solidFill>
-                  <a:srgbClr val="44506B"/>
-                </a:solidFill>
-                <a:latin typeface="Calibri" pitchFamily="34" charset="0"/>
-                <a:ea typeface="Calibri" pitchFamily="34" charset="-122"/>
-                <a:cs typeface="Calibri" pitchFamily="34" charset="-120"/>
-              </a:rPr>
-              <a:t>Build the account longlist</a:t>
-            </a:r>
-            <a:endParaRPr lang="en-US" sz="1250" dirty="0"/>
-          </a:p>
-          <a:p>
-            <a:pPr marL="342900" indent="-342900">
-              <a:spcAft>
-                <a:spcPts val="900"/>
-              </a:spcAft>
-              <a:buSzPct val="100000"/>
-              <a:buChar char="•"/>
-            </a:pPr>
-            <a:r>
-              <a:rPr lang="en-US" sz="1250" dirty="0">
-                <a:solidFill>
-                  <a:srgbClr val="44506B"/>
-                </a:solidFill>
-                <a:latin typeface="Calibri" pitchFamily="34" charset="0"/>
-                <a:ea typeface="Calibri" pitchFamily="34" charset="-122"/>
-                <a:cs typeface="Calibri" pitchFamily="34" charset="-120"/>
-              </a:rPr>
-              <a:t>Draft the proposition catalogue</a:t>
-            </a:r>
-            <a:endParaRPr lang="en-US" sz="1250" dirty="0"/>
-          </a:p>
-          <a:p>
-            <a:pPr marL="342900" indent="-342900">
-              <a:spcAft>
-                <a:spcPts val="900"/>
-              </a:spcAft>
-              <a:buSzPct val="100000"/>
-              <a:buChar char="•"/>
-            </a:pPr>
-            <a:r>
-              <a:rPr lang="en-US" sz="1250" dirty="0">
-                <a:solidFill>
-                  <a:srgbClr val="44506B"/>
-                </a:solidFill>
-                <a:latin typeface="Calibri" pitchFamily="34" charset="0"/>
-                <a:ea typeface="Calibri" pitchFamily="34" charset="-122"/>
-                <a:cs typeface="Calibri" pitchFamily="34" charset="-120"/>
-              </a:rPr>
-              <a:t>Baseline the team we have today</a:t>
-            </a:r>
-            <a:endParaRPr lang="en-US" sz="1250" dirty="0"/>
-          </a:p>
-        </p:txBody>
-      </p:sp>
-      <p:sp>
-        <p:nvSpPr>
-          <p:cNvPr id="8" name="Text 6"/>
-          <p:cNvSpPr txBox="1"/>
-          <p:nvPr/>
-        </p:nvSpPr>
-        <p:spPr>
-          <a:xfrm>
-            <a:off x="914400" y="4892040"/>
-            <a:ext cx="2880360" cy="594360"/>
-          </a:xfrm>
-          <a:prstGeom prst="rect">
-            <a:avLst/>
-          </a:prstGeom>
-          <a:noFill/>
-          <a:ln/>
-        </p:spPr>
-        <p:txBody>
-          <a:bodyPr wrap="square" lIns="0" tIns="0" rIns="0" bIns="0" rtlCol="0" anchor="ctr"/>
-          <a:lstStyle/>
-          <a:p>
-            <a:pPr indent="0" marL="0">
-              <a:buNone/>
-            </a:pPr>
-            <a:r>
-              <a:rPr lang="en-US" sz="1200" b="1" dirty="0">
-                <a:solidFill>
-                  <a:srgbClr val="B8862B"/>
-                </a:solidFill>
-                <a:latin typeface="Calibri" pitchFamily="34" charset="0"/>
-                <a:ea typeface="Calibri" pitchFamily="34" charset="-122"/>
-                <a:cs typeface="Calibri" pitchFamily="34" charset="-120"/>
-              </a:rPr>
-              <a:t>Gate: agreed market and segment priorities</a:t>
-            </a:r>
-            <a:endParaRPr lang="en-US" sz="1200" dirty="0"/>
-          </a:p>
-        </p:txBody>
-      </p:sp>
-      <p:sp>
-        <p:nvSpPr>
-          <p:cNvPr id="9" name="Text 7"/>
-          <p:cNvSpPr txBox="1"/>
-          <p:nvPr/>
-        </p:nvSpPr>
-        <p:spPr>
-          <a:xfrm>
-            <a:off x="4096512" y="3474720"/>
-            <a:ext cx="256032" cy="457200"/>
+            <a:off x="914400" y="2468880"/>
+            <a:ext cx="1402080" cy="1051560"/>
           </a:xfrm>
           <a:prstGeom prst="rect">
             <a:avLst/>
@@ -11520,17 +12850,78 @@
               <a:buNone/>
             </a:pPr>
             <a:r>
-              <a:rPr lang="en-US" sz="2000" dirty="0">
-                <a:solidFill>
-                  <a:srgbClr val="8792AB"/>
-                </a:solidFill>
-                <a:latin typeface="Calibri" pitchFamily="34" charset="0"/>
-                <a:ea typeface="Calibri" pitchFamily="34" charset="-122"/>
-                <a:cs typeface="Calibri" pitchFamily="34" charset="-120"/>
-              </a:rPr>
-              <a:t>→</a:t>
-            </a:r>
-            <a:endParaRPr lang="en-US" sz="2000" dirty="0"/>
+              <a:rPr lang="en-US" sz="1700" b="1" dirty="0">
+                <a:solidFill>
+                  <a:srgbClr val="FFFFFF"/>
+                </a:solidFill>
+                <a:latin typeface="Calibri" pitchFamily="34" charset="0"/>
+                <a:ea typeface="Calibri" pitchFamily="34" charset="-122"/>
+                <a:cs typeface="Calibri" pitchFamily="34" charset="-120"/>
+              </a:rPr>
+              <a:t>Oracle</a:t>
+            </a:r>
+            <a:endParaRPr lang="en-US" sz="1700" dirty="0"/>
+          </a:p>
+        </p:txBody>
+      </p:sp>
+      <p:sp>
+        <p:nvSpPr>
+          <p:cNvPr id="8" name="Shape 6"/>
+          <p:cNvSpPr/>
+          <p:nvPr/>
+        </p:nvSpPr>
+        <p:spPr>
+          <a:xfrm>
+            <a:off x="2499360" y="2468880"/>
+            <a:ext cx="1402080" cy="1051560"/>
+          </a:xfrm>
+          <a:prstGeom prst="roundRect">
+            <a:avLst>
+              <a:gd name="adj" fmla="val 8696"/>
+            </a:avLst>
+          </a:prstGeom>
+          <a:solidFill>
+            <a:srgbClr val="1E2761"/>
+          </a:solidFill>
+          <a:ln/>
+        </p:spPr>
+      </p:sp>
+      <p:sp>
+        <p:nvSpPr>
+          <p:cNvPr id="9" name="Text 7"/>
+          <p:cNvSpPr txBox="1"/>
+          <p:nvPr/>
+        </p:nvSpPr>
+        <p:spPr>
+          <a:xfrm>
+            <a:off x="2499360" y="2468880"/>
+            <a:ext cx="1402080" cy="1051560"/>
+          </a:xfrm>
+          <a:prstGeom prst="rect">
+            <a:avLst/>
+          </a:prstGeom>
+          <a:noFill/>
+          <a:ln/>
+        </p:spPr>
+        <p:txBody>
+          <a:bodyPr wrap="square" lIns="0" tIns="0" rIns="0" bIns="0" rtlCol="0" anchor="ctr"/>
+          <a:lstStyle/>
+          <a:p>
+            <a:pPr algn="ctr" indent="0" marL="0">
+              <a:buNone/>
+            </a:pPr>
+            <a:r>
+              <a:rPr lang="en-US" sz="1700" b="1" dirty="0">
+                <a:solidFill>
+                  <a:srgbClr val="FFFFFF"/>
+                </a:solidFill>
+                <a:latin typeface="Calibri" pitchFamily="34" charset="0"/>
+                <a:ea typeface="Calibri" pitchFamily="34" charset="-122"/>
+                <a:cs typeface="Calibri" pitchFamily="34" charset="-120"/>
+              </a:rPr>
+              <a:t>Google</a:t>
+            </a:r>
+            <a:endParaRPr lang="en-US" sz="1700" dirty="0"/>
           </a:p>
         </p:txBody>
       </p:sp>
@@ -11542,12 +12933,73 @@
         </p:nvSpPr>
         <p:spPr>
           <a:xfrm>
-            <a:off x="4361688" y="1828800"/>
-            <a:ext cx="3429000" cy="3840480"/>
+            <a:off x="4084320" y="2468880"/>
+            <a:ext cx="1402080" cy="1051560"/>
           </a:xfrm>
           <a:prstGeom prst="roundRect">
             <a:avLst>
-              <a:gd name="adj" fmla="val 3200"/>
+              <a:gd name="adj" fmla="val 8696"/>
+            </a:avLst>
+          </a:prstGeom>
+          <a:solidFill>
+            <a:srgbClr val="1E2761"/>
+          </a:solidFill>
+          <a:ln/>
+        </p:spPr>
+      </p:sp>
+      <p:sp>
+        <p:nvSpPr>
+          <p:cNvPr id="11" name="Text 9"/>
+          <p:cNvSpPr txBox="1"/>
+          <p:nvPr/>
+        </p:nvSpPr>
+        <p:spPr>
+          <a:xfrm>
+            <a:off x="4084320" y="2468880"/>
+            <a:ext cx="1402080" cy="1051560"/>
+          </a:xfrm>
+          <a:prstGeom prst="rect">
+            <a:avLst/>
+          </a:prstGeom>
+          <a:noFill/>
+          <a:ln/>
+        </p:spPr>
+        <p:txBody>
+          <a:bodyPr wrap="square" lIns="0" tIns="0" rIns="0" bIns="0" rtlCol="0" anchor="ctr"/>
+          <a:lstStyle/>
+          <a:p>
+            <a:pPr algn="ctr" indent="0" marL="0">
+              <a:buNone/>
+            </a:pPr>
+            <a:r>
+              <a:rPr lang="en-US" sz="1700" b="1" dirty="0">
+                <a:solidFill>
+                  <a:srgbClr val="FFFFFF"/>
+                </a:solidFill>
+                <a:latin typeface="Calibri" pitchFamily="34" charset="0"/>
+                <a:ea typeface="Calibri" pitchFamily="34" charset="-122"/>
+                <a:cs typeface="Calibri" pitchFamily="34" charset="-120"/>
+              </a:rPr>
+              <a:t>Amazon</a:t>
+            </a:r>
+            <a:endParaRPr lang="en-US" sz="1700" dirty="0"/>
+          </a:p>
+        </p:txBody>
+      </p:sp>
+      <p:sp>
+        <p:nvSpPr>
+          <p:cNvPr id="12" name="Shape 10"/>
+          <p:cNvSpPr/>
+          <p:nvPr/>
+        </p:nvSpPr>
+        <p:spPr>
+          <a:xfrm>
+            <a:off x="6309360" y="1828800"/>
+            <a:ext cx="5212080" cy="2057400"/>
+          </a:xfrm>
+          <a:prstGeom prst="roundRect">
+            <a:avLst>
+              <a:gd name="adj" fmla="val 5333"/>
             </a:avLst>
           </a:prstGeom>
           <a:solidFill>
@@ -11558,17 +13010,58 @@
       </p:sp>
       <p:sp>
         <p:nvSpPr>
-          <p:cNvPr id="11" name="Shape 9"/>
+          <p:cNvPr id="13" name="Text 11"/>
+          <p:cNvSpPr txBox="1"/>
+          <p:nvPr/>
+        </p:nvSpPr>
+        <p:spPr>
+          <a:xfrm>
+            <a:off x="6583680" y="1965960"/>
+            <a:ext cx="4663440" cy="365760"/>
+          </a:xfrm>
+          <a:prstGeom prst="rect">
+            <a:avLst/>
+          </a:prstGeom>
+          <a:noFill/>
+          <a:ln/>
+        </p:spPr>
+        <p:txBody>
+          <a:bodyPr wrap="square" lIns="0" tIns="0" rIns="0" bIns="0" rtlCol="0" anchor="ctr"/>
+          <a:lstStyle/>
+          <a:p>
+            <a:pPr indent="0" marL="0">
+              <a:buNone/>
+            </a:pPr>
+            <a:r>
+              <a:rPr lang="en-US" sz="1700" b="1" dirty="0">
+                <a:solidFill>
+                  <a:srgbClr val="3E5C8A"/>
+                </a:solidFill>
+                <a:latin typeface="Calibri" pitchFamily="34" charset="0"/>
+                <a:ea typeface="Calibri" pitchFamily="34" charset="-122"/>
+                <a:cs typeface="Calibri" pitchFamily="34" charset="-120"/>
+              </a:rPr>
+              <a:t>Specialised alliances</a:t>
+            </a:r>
+            <a:endParaRPr lang="en-US" sz="1700" dirty="0"/>
+          </a:p>
+        </p:txBody>
+      </p:sp>
+      <p:sp>
+        <p:nvSpPr>
+          <p:cNvPr id="14" name="Shape 12"/>
           <p:cNvSpPr/>
           <p:nvPr/>
         </p:nvSpPr>
         <p:spPr>
           <a:xfrm>
-            <a:off x="4361688" y="1828800"/>
-            <a:ext cx="3429000" cy="685800"/>
-          </a:xfrm>
-          <a:prstGeom prst="rect">
-            <a:avLst/>
+            <a:off x="6583680" y="2468880"/>
+            <a:ext cx="2240280" cy="1051560"/>
+          </a:xfrm>
+          <a:prstGeom prst="roundRect">
+            <a:avLst>
+              <a:gd name="adj" fmla="val 8696"/>
+            </a:avLst>
           </a:prstGeom>
           <a:solidFill>
             <a:srgbClr val="3E5C8A"/>
@@ -11578,14 +13071,180 @@
       </p:sp>
       <p:sp>
         <p:nvSpPr>
-          <p:cNvPr id="12" name="Text 10"/>
-          <p:cNvSpPr txBox="1"/>
-          <p:nvPr/>
-        </p:nvSpPr>
-        <p:spPr>
-          <a:xfrm>
-            <a:off x="4636008" y="1828800"/>
-            <a:ext cx="2926080" cy="685800"/>
+          <p:cNvPr id="15" name="Text 13"/>
+          <p:cNvSpPr txBox="1"/>
+          <p:nvPr/>
+        </p:nvSpPr>
+        <p:spPr>
+          <a:xfrm>
+            <a:off x="6583680" y="2468880"/>
+            <a:ext cx="2240280" cy="1051560"/>
+          </a:xfrm>
+          <a:prstGeom prst="rect">
+            <a:avLst/>
+          </a:prstGeom>
+          <a:noFill/>
+          <a:ln/>
+        </p:spPr>
+        <p:txBody>
+          <a:bodyPr wrap="square" lIns="0" tIns="0" rIns="0" bIns="0" rtlCol="0" anchor="ctr"/>
+          <a:lstStyle/>
+          <a:p>
+            <a:pPr algn="ctr" indent="0" marL="0">
+              <a:buNone/>
+            </a:pPr>
+            <a:r>
+              <a:rPr lang="en-US" sz="1700" b="1" dirty="0">
+                <a:solidFill>
+                  <a:srgbClr val="FFFFFF"/>
+                </a:solidFill>
+                <a:latin typeface="Calibri" pitchFamily="34" charset="0"/>
+                <a:ea typeface="Calibri" pitchFamily="34" charset="-122"/>
+                <a:cs typeface="Calibri" pitchFamily="34" charset="-120"/>
+              </a:rPr>
+              <a:t>Temenos</a:t>
+            </a:r>
+            <a:endParaRPr lang="en-US" sz="1700" dirty="0"/>
+          </a:p>
+        </p:txBody>
+      </p:sp>
+      <p:sp>
+        <p:nvSpPr>
+          <p:cNvPr id="16" name="Shape 14"/>
+          <p:cNvSpPr/>
+          <p:nvPr/>
+        </p:nvSpPr>
+        <p:spPr>
+          <a:xfrm>
+            <a:off x="9006840" y="2468880"/>
+            <a:ext cx="2240280" cy="1051560"/>
+          </a:xfrm>
+          <a:prstGeom prst="roundRect">
+            <a:avLst>
+              <a:gd name="adj" fmla="val 8696"/>
+            </a:avLst>
+          </a:prstGeom>
+          <a:solidFill>
+            <a:srgbClr val="3E5C8A"/>
+          </a:solidFill>
+          <a:ln/>
+        </p:spPr>
+      </p:sp>
+      <p:sp>
+        <p:nvSpPr>
+          <p:cNvPr id="17" name="Text 15"/>
+          <p:cNvSpPr txBox="1"/>
+          <p:nvPr/>
+        </p:nvSpPr>
+        <p:spPr>
+          <a:xfrm>
+            <a:off x="9006840" y="2468880"/>
+            <a:ext cx="2240280" cy="1051560"/>
+          </a:xfrm>
+          <a:prstGeom prst="rect">
+            <a:avLst/>
+          </a:prstGeom>
+          <a:noFill/>
+          <a:ln/>
+        </p:spPr>
+        <p:txBody>
+          <a:bodyPr wrap="square" lIns="0" tIns="0" rIns="0" bIns="0" rtlCol="0" anchor="ctr"/>
+          <a:lstStyle/>
+          <a:p>
+            <a:pPr algn="ctr" indent="0" marL="0">
+              <a:buNone/>
+            </a:pPr>
+            <a:r>
+              <a:rPr lang="en-US" sz="1700" b="1" dirty="0">
+                <a:solidFill>
+                  <a:srgbClr val="FFFFFF"/>
+                </a:solidFill>
+                <a:latin typeface="Calibri" pitchFamily="34" charset="0"/>
+                <a:ea typeface="Calibri" pitchFamily="34" charset="-122"/>
+                <a:cs typeface="Calibri" pitchFamily="34" charset="-120"/>
+              </a:rPr>
+              <a:t>Intellect</a:t>
+            </a:r>
+            <a:endParaRPr lang="en-US" sz="1700" dirty="0"/>
+          </a:p>
+        </p:txBody>
+      </p:sp>
+      <p:sp>
+        <p:nvSpPr>
+          <p:cNvPr id="18" name="Shape 16"/>
+          <p:cNvSpPr/>
+          <p:nvPr/>
+        </p:nvSpPr>
+        <p:spPr>
+          <a:xfrm>
+            <a:off x="4023360" y="4023360"/>
+            <a:ext cx="4114800" cy="301752"/>
+          </a:xfrm>
+          <a:prstGeom prst="roundRect">
+            <a:avLst>
+              <a:gd name="adj" fmla="val 48485"/>
+            </a:avLst>
+          </a:prstGeom>
+          <a:solidFill>
+            <a:srgbClr val="FFFFFF"/>
+          </a:solidFill>
+          <a:ln w="12700">
+            <a:solidFill>
+              <a:srgbClr val="B8862B"/>
+            </a:solidFill>
+            <a:prstDash val="solid"/>
+          </a:ln>
+        </p:spPr>
+      </p:sp>
+      <p:sp>
+        <p:nvSpPr>
+          <p:cNvPr id="19" name="Text 17"/>
+          <p:cNvSpPr txBox="1"/>
+          <p:nvPr/>
+        </p:nvSpPr>
+        <p:spPr>
+          <a:xfrm>
+            <a:off x="4023360" y="4023360"/>
+            <a:ext cx="4114800" cy="301752"/>
+          </a:xfrm>
+          <a:prstGeom prst="rect">
+            <a:avLst/>
+          </a:prstGeom>
+          <a:noFill/>
+          <a:ln/>
+        </p:spPr>
+        <p:txBody>
+          <a:bodyPr wrap="square" lIns="0" tIns="0" rIns="0" bIns="0" rtlCol="0" anchor="ctr"/>
+          <a:lstStyle/>
+          <a:p>
+            <a:pPr algn="ctr" indent="0" marL="0">
+              <a:buNone/>
+            </a:pPr>
+            <a:r>
+              <a:rPr lang="en-US" sz="1050" i="1" dirty="0">
+                <a:solidFill>
+                  <a:srgbClr val="B8862B"/>
+                </a:solidFill>
+                <a:latin typeface="Calibri" pitchFamily="34" charset="0"/>
+                <a:ea typeface="Calibri" pitchFamily="34" charset="-122"/>
+                <a:cs typeface="Calibri" pitchFamily="34" charset="-120"/>
+              </a:rPr>
+              <a:t>further alliances to be defined in the cycle</a:t>
+            </a:r>
+            <a:endParaRPr lang="en-US" sz="1050" dirty="0"/>
+          </a:p>
+        </p:txBody>
+      </p:sp>
+      <p:sp>
+        <p:nvSpPr>
+          <p:cNvPr id="20" name="Text 18"/>
+          <p:cNvSpPr txBox="1"/>
+          <p:nvPr/>
+        </p:nvSpPr>
+        <p:spPr>
+          <a:xfrm>
+            <a:off x="640080" y="4617720"/>
+            <a:ext cx="10881360" cy="320040"/>
           </a:xfrm>
           <a:prstGeom prst="rect">
             <a:avLst/>
@@ -11601,238 +13260,32 @@
               <a:buNone/>
             </a:pPr>
             <a:r>
-              <a:rPr lang="en-US" sz="1800" b="1" dirty="0">
-                <a:solidFill>
-                  <a:srgbClr val="FFFFFF"/>
-                </a:solidFill>
-                <a:latin typeface="Calibri" pitchFamily="34" charset="0"/>
-                <a:ea typeface="Calibri" pitchFamily="34" charset="-122"/>
-                <a:cs typeface="Calibri" pitchFamily="34" charset="-120"/>
-              </a:rPr>
-              <a:t>Week 2  ·  Define</a:t>
-            </a:r>
-            <a:endParaRPr lang="en-US" sz="1800" dirty="0"/>
-          </a:p>
-        </p:txBody>
-      </p:sp>
-      <p:sp>
-        <p:nvSpPr>
-          <p:cNvPr id="13" name="Text 11"/>
-          <p:cNvSpPr txBox="1"/>
-          <p:nvPr/>
-        </p:nvSpPr>
-        <p:spPr>
-          <a:xfrm>
-            <a:off x="4636008" y="2743200"/>
-            <a:ext cx="2880360" cy="1920240"/>
-          </a:xfrm>
-          <a:prstGeom prst="rect">
-            <a:avLst/>
-          </a:prstGeom>
-          <a:noFill/>
-          <a:ln/>
-        </p:spPr>
-        <p:txBody>
-          <a:bodyPr wrap="square" lIns="0" tIns="0" rIns="0" bIns="0" rtlCol="0" anchor="ctr"/>
-          <a:lstStyle/>
-          <a:p>
-            <a:pPr marL="342900" indent="-342900">
-              <a:spcAft>
-                <a:spcPts val="900"/>
-              </a:spcAft>
-              <a:buSzPct val="100000"/>
-              <a:buChar char="•"/>
-            </a:pPr>
-            <a:r>
-              <a:rPr lang="en-US" sz="1250" dirty="0">
-                <a:solidFill>
-                  <a:srgbClr val="44506B"/>
-                </a:solidFill>
-                <a:latin typeface="Calibri" pitchFamily="34" charset="0"/>
-                <a:ea typeface="Calibri" pitchFamily="34" charset="-122"/>
-                <a:cs typeface="Calibri" pitchFamily="34" charset="-120"/>
-              </a:rPr>
-              <a:t>Lock propositions and permitted variants</a:t>
-            </a:r>
-            <a:endParaRPr lang="en-US" sz="1250" dirty="0"/>
-          </a:p>
-          <a:p>
-            <a:pPr marL="342900" indent="-342900">
-              <a:spcAft>
-                <a:spcPts val="900"/>
-              </a:spcAft>
-              <a:buSzPct val="100000"/>
-              <a:buChar char="•"/>
-            </a:pPr>
-            <a:r>
-              <a:rPr lang="en-US" sz="1250" dirty="0">
-                <a:solidFill>
-                  <a:srgbClr val="44506B"/>
-                </a:solidFill>
-                <a:latin typeface="Calibri" pitchFamily="34" charset="0"/>
-                <a:ea typeface="Calibri" pitchFamily="34" charset="-122"/>
-                <a:cs typeface="Calibri" pitchFamily="34" charset="-120"/>
-              </a:rPr>
-              <a:t>Benchmark deal sizes and pricing</a:t>
-            </a:r>
-            <a:endParaRPr lang="en-US" sz="1250" dirty="0"/>
-          </a:p>
-          <a:p>
-            <a:pPr marL="342900" indent="-342900">
-              <a:spcAft>
-                <a:spcPts val="900"/>
-              </a:spcAft>
-              <a:buSzPct val="100000"/>
-              <a:buChar char="•"/>
-            </a:pPr>
-            <a:r>
-              <a:rPr lang="en-US" sz="1250" dirty="0">
-                <a:solidFill>
-                  <a:srgbClr val="44506B"/>
-                </a:solidFill>
-                <a:latin typeface="Calibri" pitchFamily="34" charset="0"/>
-                <a:ea typeface="Calibri" pitchFamily="34" charset="-122"/>
-                <a:cs typeface="Calibri" pitchFamily="34" charset="-120"/>
-              </a:rPr>
-              <a:t>Shortlist target accounts</a:t>
-            </a:r>
-            <a:endParaRPr lang="en-US" sz="1250" dirty="0"/>
-          </a:p>
-          <a:p>
-            <a:pPr marL="342900" indent="-342900">
-              <a:spcAft>
-                <a:spcPts val="900"/>
-              </a:spcAft>
-              <a:buSzPct val="100000"/>
-              <a:buChar char="•"/>
-            </a:pPr>
-            <a:r>
-              <a:rPr lang="en-US" sz="1250" dirty="0">
-                <a:solidFill>
-                  <a:srgbClr val="44506B"/>
-                </a:solidFill>
-                <a:latin typeface="Calibri" pitchFamily="34" charset="0"/>
-                <a:ea typeface="Calibri" pitchFamily="34" charset="-122"/>
-                <a:cs typeface="Calibri" pitchFamily="34" charset="-120"/>
-              </a:rPr>
-              <a:t>Size the capacity each target implies</a:t>
-            </a:r>
-            <a:endParaRPr lang="en-US" sz="1250" dirty="0"/>
-          </a:p>
-        </p:txBody>
-      </p:sp>
-      <p:sp>
-        <p:nvSpPr>
-          <p:cNvPr id="14" name="Text 12"/>
-          <p:cNvSpPr txBox="1"/>
-          <p:nvPr/>
-        </p:nvSpPr>
-        <p:spPr>
-          <a:xfrm>
-            <a:off x="4636008" y="4892040"/>
-            <a:ext cx="2880360" cy="594360"/>
-          </a:xfrm>
-          <a:prstGeom prst="rect">
-            <a:avLst/>
-          </a:prstGeom>
-          <a:noFill/>
-          <a:ln/>
-        </p:spPr>
-        <p:txBody>
-          <a:bodyPr wrap="square" lIns="0" tIns="0" rIns="0" bIns="0" rtlCol="0" anchor="ctr"/>
-          <a:lstStyle/>
-          <a:p>
-            <a:pPr indent="0" marL="0">
-              <a:buNone/>
-            </a:pPr>
-            <a:r>
-              <a:rPr lang="en-US" sz="1200" b="1" dirty="0">
-                <a:solidFill>
-                  <a:srgbClr val="B8862B"/>
-                </a:solidFill>
-                <a:latin typeface="Calibri" pitchFamily="34" charset="0"/>
-                <a:ea typeface="Calibri" pitchFamily="34" charset="-122"/>
-                <a:cs typeface="Calibri" pitchFamily="34" charset="-120"/>
-              </a:rPr>
-              <a:t>Gate: agreed catalogue and shortlist</a:t>
-            </a:r>
-            <a:endParaRPr lang="en-US" sz="1200" dirty="0"/>
-          </a:p>
-        </p:txBody>
-      </p:sp>
-      <p:sp>
-        <p:nvSpPr>
-          <p:cNvPr id="15" name="Text 13"/>
-          <p:cNvSpPr txBox="1"/>
-          <p:nvPr/>
-        </p:nvSpPr>
-        <p:spPr>
-          <a:xfrm>
-            <a:off x="7818120" y="3474720"/>
-            <a:ext cx="256032" cy="457200"/>
-          </a:xfrm>
-          <a:prstGeom prst="rect">
-            <a:avLst/>
-          </a:prstGeom>
-          <a:noFill/>
-          <a:ln/>
-        </p:spPr>
-        <p:txBody>
-          <a:bodyPr wrap="square" lIns="0" tIns="0" rIns="0" bIns="0" rtlCol="0" anchor="ctr"/>
-          <a:lstStyle/>
-          <a:p>
-            <a:pPr algn="ctr" indent="0" marL="0">
-              <a:buNone/>
-            </a:pPr>
-            <a:r>
-              <a:rPr lang="en-US" sz="2000" dirty="0">
-                <a:solidFill>
-                  <a:srgbClr val="8792AB"/>
-                </a:solidFill>
-                <a:latin typeface="Calibri" pitchFamily="34" charset="0"/>
-                <a:ea typeface="Calibri" pitchFamily="34" charset="-122"/>
-                <a:cs typeface="Calibri" pitchFamily="34" charset="-120"/>
-              </a:rPr>
-              <a:t>→</a:t>
-            </a:r>
-            <a:endParaRPr lang="en-US" sz="2000" dirty="0"/>
-          </a:p>
-        </p:txBody>
-      </p:sp>
-      <p:sp>
-        <p:nvSpPr>
-          <p:cNvPr id="16" name="Shape 14"/>
+              <a:rPr lang="en-US" sz="1400" b="1" dirty="0">
+                <a:solidFill>
+                  <a:srgbClr val="16203A"/>
+                </a:solidFill>
+                <a:latin typeface="Calibri" pitchFamily="34" charset="0"/>
+                <a:ea typeface="Calibri" pitchFamily="34" charset="-122"/>
+                <a:cs typeface="Calibri" pitchFamily="34" charset="-120"/>
+              </a:rPr>
+              <a:t>For every alliance the plan must answer:</a:t>
+            </a:r>
+            <a:endParaRPr lang="en-US" sz="1400" dirty="0"/>
+          </a:p>
+        </p:txBody>
+      </p:sp>
+      <p:sp>
+        <p:nvSpPr>
+          <p:cNvPr id="21" name="Shape 19"/>
           <p:cNvSpPr/>
           <p:nvPr/>
         </p:nvSpPr>
         <p:spPr>
           <a:xfrm>
-            <a:off x="8083296" y="1828800"/>
-            <a:ext cx="3429000" cy="3840480"/>
-          </a:xfrm>
-          <a:prstGeom prst="roundRect">
-            <a:avLst>
-              <a:gd name="adj" fmla="val 3200"/>
-            </a:avLst>
-          </a:prstGeom>
-          <a:solidFill>
-            <a:srgbClr val="EDF2FA"/>
-          </a:solidFill>
-          <a:ln/>
-        </p:spPr>
-      </p:sp>
-      <p:sp>
-        <p:nvSpPr>
-          <p:cNvPr id="17" name="Shape 15"/>
-          <p:cNvSpPr/>
-          <p:nvPr/>
-        </p:nvSpPr>
-        <p:spPr>
-          <a:xfrm>
-            <a:off x="8083296" y="1828800"/>
-            <a:ext cx="3429000" cy="685800"/>
-          </a:xfrm>
-          <a:prstGeom prst="rect">
+            <a:off x="640080" y="5029200"/>
+            <a:ext cx="310896" cy="310896"/>
+          </a:xfrm>
+          <a:prstGeom prst="ellipse">
             <a:avLst/>
           </a:prstGeom>
           <a:solidFill>
@@ -11843,14 +13296,53 @@
       </p:sp>
       <p:sp>
         <p:nvSpPr>
-          <p:cNvPr id="18" name="Text 16"/>
-          <p:cNvSpPr txBox="1"/>
-          <p:nvPr/>
-        </p:nvSpPr>
-        <p:spPr>
-          <a:xfrm>
-            <a:off x="8357616" y="1828800"/>
-            <a:ext cx="2926080" cy="685800"/>
+          <p:cNvPr id="22" name="Text 20"/>
+          <p:cNvSpPr txBox="1"/>
+          <p:nvPr/>
+        </p:nvSpPr>
+        <p:spPr>
+          <a:xfrm>
+            <a:off x="640080" y="5029200"/>
+            <a:ext cx="310896" cy="310896"/>
+          </a:xfrm>
+          <a:prstGeom prst="rect">
+            <a:avLst/>
+          </a:prstGeom>
+          <a:noFill/>
+          <a:ln/>
+        </p:spPr>
+        <p:txBody>
+          <a:bodyPr wrap="square" lIns="0" tIns="0" rIns="0" bIns="0" rtlCol="0" anchor="ctr"/>
+          <a:lstStyle/>
+          <a:p>
+            <a:pPr algn="ctr" indent="0" marL="0">
+              <a:buNone/>
+            </a:pPr>
+            <a:r>
+              <a:rPr lang="en-US" sz="1200" b="1" dirty="0">
+                <a:solidFill>
+                  <a:srgbClr val="FFFFFF"/>
+                </a:solidFill>
+                <a:latin typeface="Calibri" pitchFamily="34" charset="0"/>
+                <a:ea typeface="Calibri" pitchFamily="34" charset="-122"/>
+                <a:cs typeface="Calibri" pitchFamily="34" charset="-120"/>
+              </a:rPr>
+              <a:t>1</a:t>
+            </a:r>
+            <a:endParaRPr lang="en-US" sz="1200" dirty="0"/>
+          </a:p>
+        </p:txBody>
+      </p:sp>
+      <p:sp>
+        <p:nvSpPr>
+          <p:cNvPr id="23" name="Text 21"/>
+          <p:cNvSpPr txBox="1"/>
+          <p:nvPr/>
+        </p:nvSpPr>
+        <p:spPr>
+          <a:xfrm>
+            <a:off x="1097280" y="4992624"/>
+            <a:ext cx="2377440" cy="320040"/>
           </a:xfrm>
           <a:prstGeom prst="rect">
             <a:avLst/>
@@ -11866,157 +13358,30 @@
               <a:buNone/>
             </a:pPr>
             <a:r>
-              <a:rPr lang="en-US" sz="1800" b="1" dirty="0">
-                <a:solidFill>
-                  <a:srgbClr val="FFFFFF"/>
-                </a:solidFill>
-                <a:latin typeface="Calibri" pitchFamily="34" charset="0"/>
-                <a:ea typeface="Calibri" pitchFamily="34" charset="-122"/>
-                <a:cs typeface="Calibri" pitchFamily="34" charset="-120"/>
-              </a:rPr>
-              <a:t>Week 3  ·  Commit</a:t>
-            </a:r>
-            <a:endParaRPr lang="en-US" sz="1800" dirty="0"/>
-          </a:p>
-        </p:txBody>
-      </p:sp>
-      <p:sp>
-        <p:nvSpPr>
-          <p:cNvPr id="19" name="Text 17"/>
-          <p:cNvSpPr txBox="1"/>
-          <p:nvPr/>
-        </p:nvSpPr>
-        <p:spPr>
-          <a:xfrm>
-            <a:off x="8357616" y="2743200"/>
-            <a:ext cx="2880360" cy="1920240"/>
-          </a:xfrm>
-          <a:prstGeom prst="rect">
-            <a:avLst/>
-          </a:prstGeom>
-          <a:noFill/>
-          <a:ln/>
-        </p:spPr>
-        <p:txBody>
-          <a:bodyPr wrap="square" lIns="0" tIns="0" rIns="0" bIns="0" rtlCol="0" anchor="ctr"/>
-          <a:lstStyle/>
-          <a:p>
-            <a:pPr marL="342900" indent="-342900">
-              <a:spcAft>
-                <a:spcPts val="900"/>
-              </a:spcAft>
-              <a:buSzPct val="100000"/>
-              <a:buChar char="•"/>
-            </a:pPr>
-            <a:r>
-              <a:rPr lang="en-US" sz="1250" dirty="0">
-                <a:solidFill>
-                  <a:srgbClr val="44506B"/>
-                </a:solidFill>
-                <a:latin typeface="Calibri" pitchFamily="34" charset="0"/>
-                <a:ea typeface="Calibri" pitchFamily="34" charset="-122"/>
-                <a:cs typeface="Calibri" pitchFamily="34" charset="-120"/>
-              </a:rPr>
-              <a:t>Set revenue targets by market and offering</a:t>
-            </a:r>
-            <a:endParaRPr lang="en-US" sz="1250" dirty="0"/>
-          </a:p>
-          <a:p>
-            <a:pPr marL="342900" indent="-342900">
-              <a:spcAft>
-                <a:spcPts val="900"/>
-              </a:spcAft>
-              <a:buSzPct val="100000"/>
-              <a:buChar char="•"/>
-            </a:pPr>
-            <a:r>
-              <a:rPr lang="en-US" sz="1250" dirty="0">
-                <a:solidFill>
-                  <a:srgbClr val="44506B"/>
-                </a:solidFill>
-                <a:latin typeface="Calibri" pitchFamily="34" charset="0"/>
-                <a:ea typeface="Calibri" pitchFamily="34" charset="-122"/>
-                <a:cs typeface="Calibri" pitchFamily="34" charset="-120"/>
-              </a:rPr>
-              <a:t>Assign an owner to every account</a:t>
-            </a:r>
-            <a:endParaRPr lang="en-US" sz="1250" dirty="0"/>
-          </a:p>
-          <a:p>
-            <a:pPr marL="342900" indent="-342900">
-              <a:spcAft>
-                <a:spcPts val="900"/>
-              </a:spcAft>
-              <a:buSzPct val="100000"/>
-              <a:buChar char="•"/>
-            </a:pPr>
-            <a:r>
-              <a:rPr lang="en-US" sz="1250" dirty="0">
-                <a:solidFill>
-                  <a:srgbClr val="44506B"/>
-                </a:solidFill>
-                <a:latin typeface="Calibri" pitchFamily="34" charset="0"/>
-                <a:ea typeface="Calibri" pitchFamily="34" charset="-122"/>
-                <a:cs typeface="Calibri" pitchFamily="34" charset="-120"/>
-              </a:rPr>
-              <a:t>Agree the team model and recruitment plan</a:t>
-            </a:r>
-            <a:endParaRPr lang="en-US" sz="1250" dirty="0"/>
-          </a:p>
-          <a:p>
-            <a:pPr marL="342900" indent="-342900">
-              <a:spcAft>
-                <a:spcPts val="900"/>
-              </a:spcAft>
-              <a:buSzPct val="100000"/>
-              <a:buChar char="•"/>
-            </a:pPr>
-            <a:r>
-              <a:rPr lang="en-US" sz="1250" dirty="0">
-                <a:solidFill>
-                  <a:srgbClr val="44506B"/>
-                </a:solidFill>
-                <a:latin typeface="Calibri" pitchFamily="34" charset="0"/>
-                <a:ea typeface="Calibri" pitchFamily="34" charset="-122"/>
-                <a:cs typeface="Calibri" pitchFamily="34" charset="-120"/>
-              </a:rPr>
-              <a:t>Set the eminence calendar</a:t>
-            </a:r>
-            <a:endParaRPr lang="en-US" sz="1250" dirty="0"/>
-          </a:p>
-          <a:p>
-            <a:pPr marL="342900" indent="-342900">
-              <a:spcAft>
-                <a:spcPts val="900"/>
-              </a:spcAft>
-              <a:buSzPct val="100000"/>
-              <a:buChar char="•"/>
-            </a:pPr>
-            <a:r>
-              <a:rPr lang="en-US" sz="1250" dirty="0">
-                <a:solidFill>
-                  <a:srgbClr val="44506B"/>
-                </a:solidFill>
-                <a:latin typeface="Calibri" pitchFamily="34" charset="0"/>
-                <a:ea typeface="Calibri" pitchFamily="34" charset="-122"/>
-                <a:cs typeface="Calibri" pitchFamily="34" charset="-120"/>
-              </a:rPr>
-              <a:t>Build the activation plan and sign off</a:t>
-            </a:r>
-            <a:endParaRPr lang="en-US" sz="1250" dirty="0"/>
-          </a:p>
-        </p:txBody>
-      </p:sp>
-      <p:sp>
-        <p:nvSpPr>
-          <p:cNvPr id="20" name="Text 18"/>
-          <p:cNvSpPr txBox="1"/>
-          <p:nvPr/>
-        </p:nvSpPr>
-        <p:spPr>
-          <a:xfrm>
-            <a:off x="8357616" y="4892040"/>
-            <a:ext cx="2880360" cy="594360"/>
+              <a:rPr lang="en-US" sz="1300" b="1" dirty="0">
+                <a:solidFill>
+                  <a:srgbClr val="16203A"/>
+                </a:solidFill>
+                <a:latin typeface="Calibri" pitchFamily="34" charset="0"/>
+                <a:ea typeface="Calibri" pitchFamily="34" charset="-122"/>
+                <a:cs typeface="Calibri" pitchFamily="34" charset="-120"/>
+              </a:rPr>
+              <a:t>What we leverage it for</a:t>
+            </a:r>
+            <a:endParaRPr lang="en-US" sz="1300" dirty="0"/>
+          </a:p>
+        </p:txBody>
+      </p:sp>
+      <p:sp>
+        <p:nvSpPr>
+          <p:cNvPr id="24" name="Text 22"/>
+          <p:cNvSpPr txBox="1"/>
+          <p:nvPr/>
+        </p:nvSpPr>
+        <p:spPr>
+          <a:xfrm>
+            <a:off x="3474720" y="4992624"/>
+            <a:ext cx="2514600" cy="411480"/>
           </a:xfrm>
           <a:prstGeom prst="rect">
             <a:avLst/>
@@ -12032,15 +13397,74 @@
               <a:buNone/>
             </a:pPr>
             <a:r>
+              <a:rPr lang="en-US" sz="1200" dirty="0">
+                <a:solidFill>
+                  <a:srgbClr val="44506B"/>
+                </a:solidFill>
+                <a:latin typeface="Calibri" pitchFamily="34" charset="0"/>
+                <a:ea typeface="Calibri" pitchFamily="34" charset="-122"/>
+                <a:cs typeface="Calibri" pitchFamily="34" charset="-120"/>
+              </a:rPr>
+              <a:t>Which propositions and which pillars it sits behind</a:t>
+            </a:r>
+            <a:endParaRPr lang="en-US" sz="1200" dirty="0"/>
+          </a:p>
+        </p:txBody>
+      </p:sp>
+      <p:sp>
+        <p:nvSpPr>
+          <p:cNvPr id="25" name="Shape 23"/>
+          <p:cNvSpPr/>
+          <p:nvPr/>
+        </p:nvSpPr>
+        <p:spPr>
+          <a:xfrm>
+            <a:off x="6263640" y="5029200"/>
+            <a:ext cx="310896" cy="310896"/>
+          </a:xfrm>
+          <a:prstGeom prst="ellipse">
+            <a:avLst/>
+          </a:prstGeom>
+          <a:solidFill>
+            <a:srgbClr val="1E2761"/>
+          </a:solidFill>
+          <a:ln/>
+        </p:spPr>
+      </p:sp>
+      <p:sp>
+        <p:nvSpPr>
+          <p:cNvPr id="26" name="Text 24"/>
+          <p:cNvSpPr txBox="1"/>
+          <p:nvPr/>
+        </p:nvSpPr>
+        <p:spPr>
+          <a:xfrm>
+            <a:off x="6263640" y="5029200"/>
+            <a:ext cx="310896" cy="310896"/>
+          </a:xfrm>
+          <a:prstGeom prst="rect">
+            <a:avLst/>
+          </a:prstGeom>
+          <a:noFill/>
+          <a:ln/>
+        </p:spPr>
+        <p:txBody>
+          <a:bodyPr wrap="square" lIns="0" tIns="0" rIns="0" bIns="0" rtlCol="0" anchor="ctr"/>
+          <a:lstStyle/>
+          <a:p>
+            <a:pPr algn="ctr" indent="0" marL="0">
+              <a:buNone/>
+            </a:pPr>
+            <a:r>
               <a:rPr lang="en-US" sz="1200" b="1" dirty="0">
                 <a:solidFill>
-                  <a:srgbClr val="B8862B"/>
-                </a:solidFill>
-                <a:latin typeface="Calibri" pitchFamily="34" charset="0"/>
-                <a:ea typeface="Calibri" pitchFamily="34" charset="-122"/>
-                <a:cs typeface="Calibri" pitchFamily="34" charset="-120"/>
-              </a:rPr>
-              <a:t>Gate: strategy signed off</a:t>
+                  <a:srgbClr val="FFFFFF"/>
+                </a:solidFill>
+                <a:latin typeface="Calibri" pitchFamily="34" charset="0"/>
+                <a:ea typeface="Calibri" pitchFamily="34" charset="-122"/>
+                <a:cs typeface="Calibri" pitchFamily="34" charset="-120"/>
+              </a:rPr>
+              <a:t>2</a:t>
             </a:r>
             <a:endParaRPr lang="en-US" sz="1200" dirty="0"/>
           </a:p>
@@ -12048,14 +13472,14 @@
       </p:sp>
       <p:sp>
         <p:nvSpPr>
-          <p:cNvPr id="21" name="Text 19"/>
-          <p:cNvSpPr txBox="1"/>
-          <p:nvPr/>
-        </p:nvSpPr>
-        <p:spPr>
-          <a:xfrm>
-            <a:off x="640080" y="5852160"/>
-            <a:ext cx="5486400" cy="320040"/>
+          <p:cNvPr id="27" name="Text 25"/>
+          <p:cNvSpPr txBox="1"/>
+          <p:nvPr/>
+        </p:nvSpPr>
+        <p:spPr>
+          <a:xfrm>
+            <a:off x="6720840" y="4992624"/>
+            <a:ext cx="2377440" cy="320040"/>
           </a:xfrm>
           <a:prstGeom prst="rect">
             <a:avLst/>
@@ -12071,15 +13495,328 @@
               <a:buNone/>
             </a:pPr>
             <a:r>
-              <a:rPr lang="en-US" sz="1200" i="1" dirty="0">
-                <a:solidFill>
-                  <a:srgbClr val="8792AB"/>
-                </a:solidFill>
-                <a:latin typeface="Calibri" pitchFamily="34" charset="0"/>
-                <a:ea typeface="Calibri" pitchFamily="34" charset="-122"/>
-                <a:cs typeface="Calibri" pitchFamily="34" charset="-120"/>
-              </a:rPr>
-              <a:t>Start date to be defined at kick-off.</a:t>
+              <a:rPr lang="en-US" sz="1300" b="1" dirty="0">
+                <a:solidFill>
+                  <a:srgbClr val="16203A"/>
+                </a:solidFill>
+                <a:latin typeface="Calibri" pitchFamily="34" charset="0"/>
+                <a:ea typeface="Calibri" pitchFamily="34" charset="-122"/>
+                <a:cs typeface="Calibri" pitchFamily="34" charset="-120"/>
+              </a:rPr>
+              <a:t>What the relationship is</a:t>
+            </a:r>
+            <a:endParaRPr lang="en-US" sz="1300" dirty="0"/>
+          </a:p>
+        </p:txBody>
+      </p:sp>
+      <p:sp>
+        <p:nvSpPr>
+          <p:cNvPr id="28" name="Text 26"/>
+          <p:cNvSpPr txBox="1"/>
+          <p:nvPr/>
+        </p:nvSpPr>
+        <p:spPr>
+          <a:xfrm>
+            <a:off x="9098280" y="4992624"/>
+            <a:ext cx="2514600" cy="411480"/>
+          </a:xfrm>
+          <a:prstGeom prst="rect">
+            <a:avLst/>
+          </a:prstGeom>
+          <a:noFill/>
+          <a:ln/>
+        </p:spPr>
+        <p:txBody>
+          <a:bodyPr wrap="square" lIns="0" tIns="0" rIns="0" bIns="0" rtlCol="0" anchor="ctr"/>
+          <a:lstStyle/>
+          <a:p>
+            <a:pPr indent="0" marL="0">
+              <a:buNone/>
+            </a:pPr>
+            <a:r>
+              <a:rPr lang="en-US" sz="1200" dirty="0">
+                <a:solidFill>
+                  <a:srgbClr val="44506B"/>
+                </a:solidFill>
+                <a:latin typeface="Calibri" pitchFamily="34" charset="0"/>
+                <a:ea typeface="Calibri" pitchFamily="34" charset="-122"/>
+                <a:cs typeface="Calibri" pitchFamily="34" charset="-120"/>
+              </a:rPr>
+              <a:t>Co-sell, resell, delivery partner or referral</a:t>
+            </a:r>
+            <a:endParaRPr lang="en-US" sz="1200" dirty="0"/>
+          </a:p>
+        </p:txBody>
+      </p:sp>
+      <p:sp>
+        <p:nvSpPr>
+          <p:cNvPr id="29" name="Shape 27"/>
+          <p:cNvSpPr/>
+          <p:nvPr/>
+        </p:nvSpPr>
+        <p:spPr>
+          <a:xfrm>
+            <a:off x="640080" y="5715000"/>
+            <a:ext cx="310896" cy="310896"/>
+          </a:xfrm>
+          <a:prstGeom prst="ellipse">
+            <a:avLst/>
+          </a:prstGeom>
+          <a:solidFill>
+            <a:srgbClr val="3E5C8A"/>
+          </a:solidFill>
+          <a:ln/>
+        </p:spPr>
+      </p:sp>
+      <p:sp>
+        <p:nvSpPr>
+          <p:cNvPr id="30" name="Text 28"/>
+          <p:cNvSpPr txBox="1"/>
+          <p:nvPr/>
+        </p:nvSpPr>
+        <p:spPr>
+          <a:xfrm>
+            <a:off x="640080" y="5715000"/>
+            <a:ext cx="310896" cy="310896"/>
+          </a:xfrm>
+          <a:prstGeom prst="rect">
+            <a:avLst/>
+          </a:prstGeom>
+          <a:noFill/>
+          <a:ln/>
+        </p:spPr>
+        <p:txBody>
+          <a:bodyPr wrap="square" lIns="0" tIns="0" rIns="0" bIns="0" rtlCol="0" anchor="ctr"/>
+          <a:lstStyle/>
+          <a:p>
+            <a:pPr algn="ctr" indent="0" marL="0">
+              <a:buNone/>
+            </a:pPr>
+            <a:r>
+              <a:rPr lang="en-US" sz="1200" b="1" dirty="0">
+                <a:solidFill>
+                  <a:srgbClr val="FFFFFF"/>
+                </a:solidFill>
+                <a:latin typeface="Calibri" pitchFamily="34" charset="0"/>
+                <a:ea typeface="Calibri" pitchFamily="34" charset="-122"/>
+                <a:cs typeface="Calibri" pitchFamily="34" charset="-120"/>
+              </a:rPr>
+              <a:t>3</a:t>
+            </a:r>
+            <a:endParaRPr lang="en-US" sz="1200" dirty="0"/>
+          </a:p>
+        </p:txBody>
+      </p:sp>
+      <p:sp>
+        <p:nvSpPr>
+          <p:cNvPr id="31" name="Text 29"/>
+          <p:cNvSpPr txBox="1"/>
+          <p:nvPr/>
+        </p:nvSpPr>
+        <p:spPr>
+          <a:xfrm>
+            <a:off x="1097280" y="5678424"/>
+            <a:ext cx="2377440" cy="320040"/>
+          </a:xfrm>
+          <a:prstGeom prst="rect">
+            <a:avLst/>
+          </a:prstGeom>
+          <a:noFill/>
+          <a:ln/>
+        </p:spPr>
+        <p:txBody>
+          <a:bodyPr wrap="square" lIns="0" tIns="0" rIns="0" bIns="0" rtlCol="0" anchor="ctr"/>
+          <a:lstStyle/>
+          <a:p>
+            <a:pPr indent="0" marL="0">
+              <a:buNone/>
+            </a:pPr>
+            <a:r>
+              <a:rPr lang="en-US" sz="1300" b="1" dirty="0">
+                <a:solidFill>
+                  <a:srgbClr val="16203A"/>
+                </a:solidFill>
+                <a:latin typeface="Calibri" pitchFamily="34" charset="0"/>
+                <a:ea typeface="Calibri" pitchFamily="34" charset="-122"/>
+                <a:cs typeface="Calibri" pitchFamily="34" charset="-120"/>
+              </a:rPr>
+              <a:t>Where it opens doors</a:t>
+            </a:r>
+            <a:endParaRPr lang="en-US" sz="1300" dirty="0"/>
+          </a:p>
+        </p:txBody>
+      </p:sp>
+      <p:sp>
+        <p:nvSpPr>
+          <p:cNvPr id="32" name="Text 30"/>
+          <p:cNvSpPr txBox="1"/>
+          <p:nvPr/>
+        </p:nvSpPr>
+        <p:spPr>
+          <a:xfrm>
+            <a:off x="3474720" y="5678424"/>
+            <a:ext cx="2514600" cy="411480"/>
+          </a:xfrm>
+          <a:prstGeom prst="rect">
+            <a:avLst/>
+          </a:prstGeom>
+          <a:noFill/>
+          <a:ln/>
+        </p:spPr>
+        <p:txBody>
+          <a:bodyPr wrap="square" lIns="0" tIns="0" rIns="0" bIns="0" rtlCol="0" anchor="ctr"/>
+          <a:lstStyle/>
+          <a:p>
+            <a:pPr indent="0" marL="0">
+              <a:buNone/>
+            </a:pPr>
+            <a:r>
+              <a:rPr lang="en-US" sz="1200" dirty="0">
+                <a:solidFill>
+                  <a:srgbClr val="44506B"/>
+                </a:solidFill>
+                <a:latin typeface="Calibri" pitchFamily="34" charset="0"/>
+                <a:ea typeface="Calibri" pitchFamily="34" charset="-122"/>
+                <a:cs typeface="Calibri" pitchFamily="34" charset="-120"/>
+              </a:rPr>
+              <a:t>Which markets and which accounts it gives us access to</a:t>
+            </a:r>
+            <a:endParaRPr lang="en-US" sz="1200" dirty="0"/>
+          </a:p>
+        </p:txBody>
+      </p:sp>
+      <p:sp>
+        <p:nvSpPr>
+          <p:cNvPr id="33" name="Shape 31"/>
+          <p:cNvSpPr/>
+          <p:nvPr/>
+        </p:nvSpPr>
+        <p:spPr>
+          <a:xfrm>
+            <a:off x="6263640" y="5715000"/>
+            <a:ext cx="310896" cy="310896"/>
+          </a:xfrm>
+          <a:prstGeom prst="ellipse">
+            <a:avLst/>
+          </a:prstGeom>
+          <a:solidFill>
+            <a:srgbClr val="3E5C8A"/>
+          </a:solidFill>
+          <a:ln/>
+        </p:spPr>
+      </p:sp>
+      <p:sp>
+        <p:nvSpPr>
+          <p:cNvPr id="34" name="Text 32"/>
+          <p:cNvSpPr txBox="1"/>
+          <p:nvPr/>
+        </p:nvSpPr>
+        <p:spPr>
+          <a:xfrm>
+            <a:off x="6263640" y="5715000"/>
+            <a:ext cx="310896" cy="310896"/>
+          </a:xfrm>
+          <a:prstGeom prst="rect">
+            <a:avLst/>
+          </a:prstGeom>
+          <a:noFill/>
+          <a:ln/>
+        </p:spPr>
+        <p:txBody>
+          <a:bodyPr wrap="square" lIns="0" tIns="0" rIns="0" bIns="0" rtlCol="0" anchor="ctr"/>
+          <a:lstStyle/>
+          <a:p>
+            <a:pPr algn="ctr" indent="0" marL="0">
+              <a:buNone/>
+            </a:pPr>
+            <a:r>
+              <a:rPr lang="en-US" sz="1200" b="1" dirty="0">
+                <a:solidFill>
+                  <a:srgbClr val="FFFFFF"/>
+                </a:solidFill>
+                <a:latin typeface="Calibri" pitchFamily="34" charset="0"/>
+                <a:ea typeface="Calibri" pitchFamily="34" charset="-122"/>
+                <a:cs typeface="Calibri" pitchFamily="34" charset="-120"/>
+              </a:rPr>
+              <a:t>4</a:t>
+            </a:r>
+            <a:endParaRPr lang="en-US" sz="1200" dirty="0"/>
+          </a:p>
+        </p:txBody>
+      </p:sp>
+      <p:sp>
+        <p:nvSpPr>
+          <p:cNvPr id="35" name="Text 33"/>
+          <p:cNvSpPr txBox="1"/>
+          <p:nvPr/>
+        </p:nvSpPr>
+        <p:spPr>
+          <a:xfrm>
+            <a:off x="6720840" y="5678424"/>
+            <a:ext cx="2377440" cy="320040"/>
+          </a:xfrm>
+          <a:prstGeom prst="rect">
+            <a:avLst/>
+          </a:prstGeom>
+          <a:noFill/>
+          <a:ln/>
+        </p:spPr>
+        <p:txBody>
+          <a:bodyPr wrap="square" lIns="0" tIns="0" rIns="0" bIns="0" rtlCol="0" anchor="ctr"/>
+          <a:lstStyle/>
+          <a:p>
+            <a:pPr indent="0" marL="0">
+              <a:buNone/>
+            </a:pPr>
+            <a:r>
+              <a:rPr lang="en-US" sz="1300" b="1" dirty="0">
+                <a:solidFill>
+                  <a:srgbClr val="16203A"/>
+                </a:solidFill>
+                <a:latin typeface="Calibri" pitchFamily="34" charset="0"/>
+                <a:ea typeface="Calibri" pitchFamily="34" charset="-122"/>
+                <a:cs typeface="Calibri" pitchFamily="34" charset="-120"/>
+              </a:rPr>
+              <a:t>What it costs us</a:t>
+            </a:r>
+            <a:endParaRPr lang="en-US" sz="1300" dirty="0"/>
+          </a:p>
+        </p:txBody>
+      </p:sp>
+      <p:sp>
+        <p:nvSpPr>
+          <p:cNvPr id="36" name="Text 34"/>
+          <p:cNvSpPr txBox="1"/>
+          <p:nvPr/>
+        </p:nvSpPr>
+        <p:spPr>
+          <a:xfrm>
+            <a:off x="9098280" y="5678424"/>
+            <a:ext cx="2514600" cy="411480"/>
+          </a:xfrm>
+          <a:prstGeom prst="rect">
+            <a:avLst/>
+          </a:prstGeom>
+          <a:noFill/>
+          <a:ln/>
+        </p:spPr>
+        <p:txBody>
+          <a:bodyPr wrap="square" lIns="0" tIns="0" rIns="0" bIns="0" rtlCol="0" anchor="ctr"/>
+          <a:lstStyle/>
+          <a:p>
+            <a:pPr indent="0" marL="0">
+              <a:buNone/>
+            </a:pPr>
+            <a:r>
+              <a:rPr lang="en-US" sz="1200" dirty="0">
+                <a:solidFill>
+                  <a:srgbClr val="44506B"/>
+                </a:solidFill>
+                <a:latin typeface="Calibri" pitchFamily="34" charset="0"/>
+                <a:ea typeface="Calibri" pitchFamily="34" charset="-122"/>
+                <a:cs typeface="Calibri" pitchFamily="34" charset="-120"/>
+              </a:rPr>
+              <a:t>Certifications, credentials and commitments they expect back</a:t>
             </a:r>
             <a:endParaRPr lang="en-US" sz="1200" dirty="0"/>
           </a:p>

</xml_diff>